<commit_message>
docs: add scheme 4 cloud preview URL for WebView rendering
Introduce approach D: a shared cloud preview web service that
publishes HTML and returns a loadable URL for iframe/WebView.
Update comparison, gap TO-BE, examples, and recommendations;
add scheme-4 illustration asset.

Co-authored-by: Lizzy67 <Lizzy67@users.noreply.github.com>
</commit_message>
<xml_diff>
--- a/docs/agent_html_preview_proposal.pptx
+++ b/docs/agent_html_preview_proposal.pptx
@@ -13,6 +13,7 @@
     <p:sldId id="261" r:id="rId12"/>
     <p:sldId id="262" r:id="rId13"/>
     <p:sldId id="263" r:id="rId14"/>
+    <p:sldId id="264" r:id="rId15"/>
   </p:sldIdLst>
   <p:sldSz cx="12191695" cy="6858000" type="screen4x3"/>
   <p:notesSz cx="6858000" cy="9144000"/>
@@ -3267,7 +3268,7 @@
                 <a:latin typeface="Calibri"/>
               </a:rPr>
               <a:t>以「个人健康分析报告」为验收场景
-图文讲解：问题 → 能力 → 竞品 → Gap → 三方案 → 示例 → 建议</a:t>
+图文讲解：问题 → 能力 → 竞品 → Gap → 四方案 → 示例 → 建议</a:t>
             </a:r>
           </a:p>
         </p:txBody>
@@ -3301,7 +3302,7 @@
                 </a:solidFill>
                 <a:latin typeface="Calibri"/>
               </a:rPr>
-              <a:t>技术分享  |  系统方案  |  落地路径</a:t>
+              <a:t>技术分享  |  系统方案  |  四路径落地</a:t>
             </a:r>
           </a:p>
         </p:txBody>
@@ -8348,7 +8349,7 @@
                 </a:solidFill>
                 <a:latin typeface="Calibri"/>
               </a:rPr>
-              <a:t>识别preview</a:t>
+              <a:t>发布预览URL</a:t>
             </a:r>
           </a:p>
         </p:txBody>
@@ -8473,7 +8474,7 @@
                 </a:solidFill>
                 <a:latin typeface="Calibri"/>
               </a:rPr>
-              <a:t>沙箱渲染</a:t>
+              <a:t>WebView打开</a:t>
             </a:r>
           </a:p>
         </p:txBody>
@@ -8690,7 +8691,7 @@
                 </a:solidFill>
                 <a:latin typeface="Calibri"/>
               </a:rPr>
-              <a:t>预览容器 iframe/WebView</a:t>
+              <a:t>预览容器 WebView/iframe</a:t>
             </a:r>
           </a:p>
         </p:txBody>
@@ -8782,7 +8783,7 @@
                 </a:solidFill>
                 <a:latin typeface="Calibri"/>
               </a:rPr>
-              <a:t>mime / preview 元数据</a:t>
+              <a:t>可打开的预览 URL 或 mime</a:t>
             </a:r>
           </a:p>
         </p:txBody>
@@ -8874,7 +8875,7 @@
                 </a:solidFill>
                 <a:latin typeface="Calibri"/>
               </a:rPr>
-              <a:t>sandbox 安全默认</a:t>
+              <a:t>sandbox / 预览域隔离</a:t>
             </a:r>
           </a:p>
         </p:txBody>
@@ -9058,7 +9059,7 @@
                 </a:solidFill>
                 <a:latin typeface="Calibri"/>
               </a:rPr>
-              <a:t>流式 / 混合 / 分享</a:t>
+              <a:t>流式 / 混合体验增强</a:t>
             </a:r>
           </a:p>
         </p:txBody>
@@ -9293,7 +9294,7 @@
                 </a:solidFill>
                 <a:latin typeface="Calibri"/>
               </a:rPr>
-              <a:t>三种实现方案对比</a:t>
+              <a:t>四种实现方案对比</a:t>
             </a:r>
           </a:p>
           <a:p>
@@ -9304,45 +9305,651 @@
                 </a:solidFill>
                 <a:latin typeface="Calibri"/>
               </a:rPr>
-              <a:t>A 下载后渲染 · B 流式实时 · C 混合（流式粗预览 + 落盘定稿）</a:t>
-            </a:r>
-          </a:p>
-        </p:txBody>
-      </p:sp>
-      <p:pic>
-        <p:nvPicPr>
-          <p:cNvPr id="7" name="Picture 6" descr="ppt-three-schemes.png"/>
-          <p:cNvPicPr>
-            <a:picLocks noChangeAspect="1"/>
-          </p:cNvPicPr>
-          <p:nvPr/>
-        </p:nvPicPr>
-        <p:blipFill>
-          <a:blip r:embed="rId2"/>
-          <a:stretch>
-            <a:fillRect/>
-          </a:stretch>
-        </p:blipFill>
-        <p:spPr>
-          <a:xfrm>
-            <a:off x="365760" y="1051560"/>
-            <a:ext cx="11430000" cy="2148840"/>
+              <a:t>A 下载后渲染 · B 流式实时 · C 混合 · D 云预览服务出可渲染链接</a:t>
+            </a:r>
+          </a:p>
+        </p:txBody>
+      </p:sp>
+      <p:sp>
+        <p:nvSpPr>
+          <p:cNvPr id="7" name="Rounded Rectangle 6"/>
+          <p:cNvSpPr/>
+          <p:nvPr/>
+        </p:nvSpPr>
+        <p:spPr>
+          <a:xfrm>
+            <a:off x="365760" y="1097280"/>
+            <a:ext cx="5669280" cy="2560320"/>
+          </a:xfrm>
+          <a:prstGeom prst="roundRect">
+            <a:avLst>
+              <a:gd name="adj" fmla="val 8000"/>
+            </a:avLst>
+          </a:prstGeom>
+          <a:solidFill>
+            <a:srgbClr val="FFFFFF"/>
+          </a:solidFill>
+          <a:ln w="12700">
+            <a:solidFill>
+              <a:srgbClr val="0D9488"/>
+            </a:solidFill>
+          </a:ln>
+        </p:spPr>
+        <p:style>
+          <a:lnRef idx="1">
+            <a:schemeClr val="accent1"/>
+          </a:lnRef>
+          <a:fillRef idx="3">
+            <a:schemeClr val="accent1"/>
+          </a:fillRef>
+          <a:effectRef idx="2">
+            <a:schemeClr val="accent1"/>
+          </a:effectRef>
+          <a:fontRef idx="minor">
+            <a:schemeClr val="lt1"/>
+          </a:fontRef>
+        </p:style>
+        <p:txBody>
+          <a:bodyPr rtlCol="0" anchor="ctr"/>
+          <a:lstStyle/>
+          <a:p>
+            <a:pPr algn="ctr"/>
+          </a:p>
+        </p:txBody>
+      </p:sp>
+      <p:sp>
+        <p:nvSpPr>
+          <p:cNvPr id="8" name="Rounded Rectangle 7"/>
+          <p:cNvSpPr/>
+          <p:nvPr/>
+        </p:nvSpPr>
+        <p:spPr>
+          <a:xfrm>
+            <a:off x="530352" y="1261872"/>
+            <a:ext cx="2377440" cy="292608"/>
+          </a:xfrm>
+          <a:prstGeom prst="roundRect">
+            <a:avLst>
+              <a:gd name="adj" fmla="val 40000"/>
+            </a:avLst>
+          </a:prstGeom>
+          <a:solidFill>
+            <a:srgbClr val="0D9488"/>
+          </a:solidFill>
+          <a:ln>
+            <a:noFill/>
+          </a:ln>
+        </p:spPr>
+        <p:style>
+          <a:lnRef idx="1">
+            <a:schemeClr val="accent1"/>
+          </a:lnRef>
+          <a:fillRef idx="3">
+            <a:schemeClr val="accent1"/>
+          </a:fillRef>
+          <a:effectRef idx="2">
+            <a:schemeClr val="accent1"/>
+          </a:effectRef>
+          <a:fontRef idx="minor">
+            <a:schemeClr val="lt1"/>
+          </a:fontRef>
+        </p:style>
+        <p:txBody>
+          <a:bodyPr rtlCol="0" anchor="ctr"/>
+          <a:lstStyle/>
+          <a:p>
+            <a:pPr algn="ctr"/>
+            <a:r>
+              <a:rPr sz="1100" b="1">
+                <a:solidFill>
+                  <a:srgbClr val="FFFFFF"/>
+                </a:solidFill>
+                <a:latin typeface="Calibri"/>
+              </a:rPr>
+              <a:t>轻量闭环</a:t>
+            </a:r>
+          </a:p>
+        </p:txBody>
+      </p:sp>
+      <p:sp>
+        <p:nvSpPr>
+          <p:cNvPr id="9" name="TextBox 8"/>
+          <p:cNvSpPr txBox="1"/>
+          <p:nvPr/>
+        </p:nvSpPr>
+        <p:spPr>
+          <a:xfrm>
+            <a:off x="548640" y="1645920"/>
+            <a:ext cx="5303520" cy="1828800"/>
           </a:xfrm>
           <a:prstGeom prst="rect">
             <a:avLst/>
           </a:prstGeom>
-        </p:spPr>
-      </p:pic>
-      <p:sp>
-        <p:nvSpPr>
-          <p:cNvPr id="8" name="Rounded Rectangle 7"/>
+          <a:noFill/>
+        </p:spPr>
+        <p:txBody>
+          <a:bodyPr wrap="square">
+            <a:spAutoFit/>
+          </a:bodyPr>
+          <a:lstStyle/>
+          <a:p>
+            <a:r>
+              <a:rPr sz="1500" b="1">
+                <a:solidFill>
+                  <a:srgbClr val="0F172A"/>
+                </a:solidFill>
+                <a:latin typeface="Calibri"/>
+              </a:rPr>
+              <a:t>方案 1 · A 下载后渲染</a:t>
+            </a:r>
+          </a:p>
+          <a:p>
+            <a:pPr>
+              <a:spcBef>
+                <a:spcPts val="600"/>
+              </a:spcBef>
+            </a:pPr>
+            <a:r>
+              <a:rPr sz="1200" b="1">
+                <a:solidFill>
+                  <a:srgbClr val="0F766E"/>
+                </a:solidFill>
+                <a:latin typeface="Calibri"/>
+              </a:rPr>
+              <a:t>流程：</a:t>
+            </a:r>
+            <a:r>
+              <a:rPr sz="1200" b="0">
+                <a:solidFill>
+                  <a:srgbClr val="334155"/>
+                </a:solidFill>
+                <a:latin typeface="Calibri"/>
+              </a:rPr>
+              <a:t>write→云空间→REST 拉全文→srcdoc/loadData</a:t>
+            </a:r>
+          </a:p>
+          <a:p>
+            <a:pPr>
+              <a:spcBef>
+                <a:spcPts val="600"/>
+              </a:spcBef>
+            </a:pPr>
+            <a:r>
+              <a:rPr sz="1200" b="1">
+                <a:solidFill>
+                  <a:srgbClr val="0F766E"/>
+                </a:solidFill>
+                <a:latin typeface="Calibri"/>
+              </a:rPr>
+              <a:t>要点：</a:t>
+            </a:r>
+            <a:r>
+              <a:rPr sz="1200" b="0">
+                <a:solidFill>
+                  <a:srgbClr val="334155"/>
+                </a:solidFill>
+                <a:latin typeface="Calibri"/>
+              </a:rPr>
+              <a:t>稳、贴合现有同步；端要自己注入 HTML</a:t>
+            </a:r>
+          </a:p>
+          <a:p>
+            <a:pPr>
+              <a:spcBef>
+                <a:spcPts val="600"/>
+              </a:spcBef>
+            </a:pPr>
+            <a:r>
+              <a:rPr sz="1200" b="1">
+                <a:solidFill>
+                  <a:srgbClr val="0F766E"/>
+                </a:solidFill>
+                <a:latin typeface="Calibri"/>
+              </a:rPr>
+              <a:t>代价：</a:t>
+            </a:r>
+            <a:r>
+              <a:rPr sz="1200" b="0">
+                <a:solidFill>
+                  <a:srgbClr val="334155"/>
+                </a:solidFill>
+                <a:latin typeface="Calibri"/>
+              </a:rPr>
+              <a:t>多文件/分享较弱</a:t>
+            </a:r>
+          </a:p>
+        </p:txBody>
+      </p:sp>
+      <p:sp>
+        <p:nvSpPr>
+          <p:cNvPr id="10" name="Rounded Rectangle 9"/>
           <p:cNvSpPr/>
           <p:nvPr/>
         </p:nvSpPr>
         <p:spPr>
           <a:xfrm>
-            <a:off x="365760" y="3337560"/>
-            <a:ext cx="3703320" cy="3154680"/>
+            <a:off x="6263640" y="1097280"/>
+            <a:ext cx="5669280" cy="2560320"/>
+          </a:xfrm>
+          <a:prstGeom prst="roundRect">
+            <a:avLst>
+              <a:gd name="adj" fmla="val 8000"/>
+            </a:avLst>
+          </a:prstGeom>
+          <a:solidFill>
+            <a:srgbClr val="FFFFFF"/>
+          </a:solidFill>
+          <a:ln w="12700">
+            <a:solidFill>
+              <a:srgbClr val="64748B"/>
+            </a:solidFill>
+          </a:ln>
+        </p:spPr>
+        <p:style>
+          <a:lnRef idx="1">
+            <a:schemeClr val="accent1"/>
+          </a:lnRef>
+          <a:fillRef idx="3">
+            <a:schemeClr val="accent1"/>
+          </a:fillRef>
+          <a:effectRef idx="2">
+            <a:schemeClr val="accent1"/>
+          </a:effectRef>
+          <a:fontRef idx="minor">
+            <a:schemeClr val="lt1"/>
+          </a:fontRef>
+        </p:style>
+        <p:txBody>
+          <a:bodyPr rtlCol="0" anchor="ctr"/>
+          <a:lstStyle/>
+          <a:p>
+            <a:pPr algn="ctr"/>
+          </a:p>
+        </p:txBody>
+      </p:sp>
+      <p:sp>
+        <p:nvSpPr>
+          <p:cNvPr id="11" name="Rounded Rectangle 10"/>
+          <p:cNvSpPr/>
+          <p:nvPr/>
+        </p:nvSpPr>
+        <p:spPr>
+          <a:xfrm>
+            <a:off x="6428232" y="1261872"/>
+            <a:ext cx="2377440" cy="292608"/>
+          </a:xfrm>
+          <a:prstGeom prst="roundRect">
+            <a:avLst>
+              <a:gd name="adj" fmla="val 40000"/>
+            </a:avLst>
+          </a:prstGeom>
+          <a:solidFill>
+            <a:srgbClr val="64748B"/>
+          </a:solidFill>
+          <a:ln>
+            <a:noFill/>
+          </a:ln>
+        </p:spPr>
+        <p:style>
+          <a:lnRef idx="1">
+            <a:schemeClr val="accent1"/>
+          </a:lnRef>
+          <a:fillRef idx="3">
+            <a:schemeClr val="accent1"/>
+          </a:fillRef>
+          <a:effectRef idx="2">
+            <a:schemeClr val="accent1"/>
+          </a:effectRef>
+          <a:fontRef idx="minor">
+            <a:schemeClr val="lt1"/>
+          </a:fontRef>
+        </p:style>
+        <p:txBody>
+          <a:bodyPr rtlCol="0" anchor="ctr"/>
+          <a:lstStyle/>
+          <a:p>
+            <a:pPr algn="ctr"/>
+            <a:r>
+              <a:rPr sz="1100" b="1">
+                <a:solidFill>
+                  <a:srgbClr val="FFFFFF"/>
+                </a:solidFill>
+                <a:latin typeface="Calibri"/>
+              </a:rPr>
+              <a:t>体验增强</a:t>
+            </a:r>
+          </a:p>
+        </p:txBody>
+      </p:sp>
+      <p:sp>
+        <p:nvSpPr>
+          <p:cNvPr id="12" name="TextBox 11"/>
+          <p:cNvSpPr txBox="1"/>
+          <p:nvPr/>
+        </p:nvSpPr>
+        <p:spPr>
+          <a:xfrm>
+            <a:off x="6446520" y="1645920"/>
+            <a:ext cx="5303520" cy="1828800"/>
+          </a:xfrm>
+          <a:prstGeom prst="rect">
+            <a:avLst/>
+          </a:prstGeom>
+          <a:noFill/>
+        </p:spPr>
+        <p:txBody>
+          <a:bodyPr wrap="square">
+            <a:spAutoFit/>
+          </a:bodyPr>
+          <a:lstStyle/>
+          <a:p>
+            <a:r>
+              <a:rPr sz="1500" b="1">
+                <a:solidFill>
+                  <a:srgbClr val="0F172A"/>
+                </a:solidFill>
+                <a:latin typeface="Calibri"/>
+              </a:rPr>
+              <a:t>方案 2 · B 流式实时渲染</a:t>
+            </a:r>
+          </a:p>
+          <a:p>
+            <a:pPr>
+              <a:spcBef>
+                <a:spcPts val="600"/>
+              </a:spcBef>
+            </a:pPr>
+            <a:r>
+              <a:rPr sz="1200" b="1">
+                <a:solidFill>
+                  <a:srgbClr val="0F766E"/>
+                </a:solidFill>
+                <a:latin typeface="Calibri"/>
+              </a:rPr>
+              <a:t>流程：</a:t>
+            </a:r>
+            <a:r>
+              <a:rPr sz="1200" b="0">
+                <a:solidFill>
+                  <a:srgbClr val="334155"/>
+                </a:solidFill>
+                <a:latin typeface="Calibri"/>
+              </a:rPr>
+              <a:t>token/delta→端 buffer→边收边刷新</a:t>
+            </a:r>
+          </a:p>
+          <a:p>
+            <a:pPr>
+              <a:spcBef>
+                <a:spcPts val="600"/>
+              </a:spcBef>
+            </a:pPr>
+            <a:r>
+              <a:rPr sz="1200" b="1">
+                <a:solidFill>
+                  <a:srgbClr val="0F766E"/>
+                </a:solidFill>
+                <a:latin typeface="Calibri"/>
+              </a:rPr>
+              <a:t>要点：</a:t>
+            </a:r>
+            <a:r>
+              <a:rPr sz="1200" b="0">
+                <a:solidFill>
+                  <a:srgbClr val="334155"/>
+                </a:solidFill>
+                <a:latin typeface="Calibri"/>
+              </a:rPr>
+              <a:t>首屏快；半截标签与脚本副作用风险高</a:t>
+            </a:r>
+          </a:p>
+          <a:p>
+            <a:pPr>
+              <a:spcBef>
+                <a:spcPts val="600"/>
+              </a:spcBef>
+            </a:pPr>
+            <a:r>
+              <a:rPr sz="1200" b="1">
+                <a:solidFill>
+                  <a:srgbClr val="0F766E"/>
+                </a:solidFill>
+                <a:latin typeface="Calibri"/>
+              </a:rPr>
+              <a:t>代价：</a:t>
+            </a:r>
+            <a:r>
+              <a:rPr sz="1200" b="0">
+                <a:solidFill>
+                  <a:srgbClr val="334155"/>
+                </a:solidFill>
+                <a:latin typeface="Calibri"/>
+              </a:rPr>
+              <a:t>需独立推送通道</a:t>
+            </a:r>
+          </a:p>
+        </p:txBody>
+      </p:sp>
+      <p:sp>
+        <p:nvSpPr>
+          <p:cNvPr id="13" name="Rounded Rectangle 12"/>
+          <p:cNvSpPr/>
+          <p:nvPr/>
+        </p:nvSpPr>
+        <p:spPr>
+          <a:xfrm>
+            <a:off x="365760" y="3840480"/>
+            <a:ext cx="5669280" cy="2560320"/>
+          </a:xfrm>
+          <a:prstGeom prst="roundRect">
+            <a:avLst>
+              <a:gd name="adj" fmla="val 8000"/>
+            </a:avLst>
+          </a:prstGeom>
+          <a:solidFill>
+            <a:srgbClr val="F0FDFA"/>
+          </a:solidFill>
+          <a:ln w="12700">
+            <a:solidFill>
+              <a:srgbClr val="0F766E"/>
+            </a:solidFill>
+          </a:ln>
+        </p:spPr>
+        <p:style>
+          <a:lnRef idx="1">
+            <a:schemeClr val="accent1"/>
+          </a:lnRef>
+          <a:fillRef idx="3">
+            <a:schemeClr val="accent1"/>
+          </a:fillRef>
+          <a:effectRef idx="2">
+            <a:schemeClr val="accent1"/>
+          </a:effectRef>
+          <a:fontRef idx="minor">
+            <a:schemeClr val="lt1"/>
+          </a:fontRef>
+        </p:style>
+        <p:txBody>
+          <a:bodyPr rtlCol="0" anchor="ctr"/>
+          <a:lstStyle/>
+          <a:p>
+            <a:pPr algn="ctr"/>
+          </a:p>
+        </p:txBody>
+      </p:sp>
+      <p:sp>
+        <p:nvSpPr>
+          <p:cNvPr id="14" name="Rounded Rectangle 13"/>
+          <p:cNvSpPr/>
+          <p:nvPr/>
+        </p:nvSpPr>
+        <p:spPr>
+          <a:xfrm>
+            <a:off x="530352" y="4005072"/>
+            <a:ext cx="2377440" cy="292608"/>
+          </a:xfrm>
+          <a:prstGeom prst="roundRect">
+            <a:avLst>
+              <a:gd name="adj" fmla="val 40000"/>
+            </a:avLst>
+          </a:prstGeom>
+          <a:solidFill>
+            <a:srgbClr val="0F766E"/>
+          </a:solidFill>
+          <a:ln>
+            <a:noFill/>
+          </a:ln>
+        </p:spPr>
+        <p:style>
+          <a:lnRef idx="1">
+            <a:schemeClr val="accent1"/>
+          </a:lnRef>
+          <a:fillRef idx="3">
+            <a:schemeClr val="accent1"/>
+          </a:fillRef>
+          <a:effectRef idx="2">
+            <a:schemeClr val="accent1"/>
+          </a:effectRef>
+          <a:fontRef idx="minor">
+            <a:schemeClr val="lt1"/>
+          </a:fontRef>
+        </p:style>
+        <p:txBody>
+          <a:bodyPr rtlCol="0" anchor="ctr"/>
+          <a:lstStyle/>
+          <a:p>
+            <a:pPr algn="ctr"/>
+            <a:r>
+              <a:rPr sz="1100" b="1">
+                <a:solidFill>
+                  <a:srgbClr val="FFFFFF"/>
+                </a:solidFill>
+                <a:latin typeface="Calibri"/>
+              </a:rPr>
+              <a:t>长报告体验</a:t>
+            </a:r>
+          </a:p>
+        </p:txBody>
+      </p:sp>
+      <p:sp>
+        <p:nvSpPr>
+          <p:cNvPr id="15" name="TextBox 14"/>
+          <p:cNvSpPr txBox="1"/>
+          <p:nvPr/>
+        </p:nvSpPr>
+        <p:spPr>
+          <a:xfrm>
+            <a:off x="548640" y="4389120"/>
+            <a:ext cx="5303520" cy="1828800"/>
+          </a:xfrm>
+          <a:prstGeom prst="rect">
+            <a:avLst/>
+          </a:prstGeom>
+          <a:noFill/>
+        </p:spPr>
+        <p:txBody>
+          <a:bodyPr wrap="square">
+            <a:spAutoFit/>
+          </a:bodyPr>
+          <a:lstStyle/>
+          <a:p>
+            <a:r>
+              <a:rPr sz="1500" b="1">
+                <a:solidFill>
+                  <a:srgbClr val="0F172A"/>
+                </a:solidFill>
+                <a:latin typeface="Calibri"/>
+              </a:rPr>
+              <a:t>方案 3 · C 混合</a:t>
+            </a:r>
+          </a:p>
+          <a:p>
+            <a:pPr>
+              <a:spcBef>
+                <a:spcPts val="600"/>
+              </a:spcBef>
+            </a:pPr>
+            <a:r>
+              <a:rPr sz="1200" b="1">
+                <a:solidFill>
+                  <a:srgbClr val="0F766E"/>
+                </a:solidFill>
+                <a:latin typeface="Calibri"/>
+              </a:rPr>
+              <a:t>流程：</a:t>
+            </a:r>
+            <a:r>
+              <a:rPr sz="1200" b="0">
+                <a:solidFill>
+                  <a:srgbClr val="334155"/>
+                </a:solidFill>
+                <a:latin typeface="Calibri"/>
+              </a:rPr>
+              <a:t>流式粗预览 + 完成后落盘定稿再替换</a:t>
+            </a:r>
+          </a:p>
+          <a:p>
+            <a:pPr>
+              <a:spcBef>
+                <a:spcPts val="600"/>
+              </a:spcBef>
+            </a:pPr>
+            <a:r>
+              <a:rPr sz="1200" b="1">
+                <a:solidFill>
+                  <a:srgbClr val="0F766E"/>
+                </a:solidFill>
+                <a:latin typeface="Calibri"/>
+              </a:rPr>
+              <a:t>要点：</a:t>
+            </a:r>
+            <a:r>
+              <a:rPr sz="1200" b="0">
+                <a:solidFill>
+                  <a:srgbClr val="334155"/>
+                </a:solidFill>
+                <a:latin typeface="Calibri"/>
+              </a:rPr>
+              <a:t>体验近 B，正确性兜底靠完整版</a:t>
+            </a:r>
+          </a:p>
+          <a:p>
+            <a:pPr>
+              <a:spcBef>
+                <a:spcPts val="600"/>
+              </a:spcBef>
+            </a:pPr>
+            <a:r>
+              <a:rPr sz="1200" b="1">
+                <a:solidFill>
+                  <a:srgbClr val="0F766E"/>
+                </a:solidFill>
+                <a:latin typeface="Calibri"/>
+              </a:rPr>
+              <a:t>代价：</a:t>
+            </a:r>
+            <a:r>
+              <a:rPr sz="1200" b="0">
+                <a:solidFill>
+                  <a:srgbClr val="334155"/>
+                </a:solidFill>
+                <a:latin typeface="Calibri"/>
+              </a:rPr>
+              <a:t>状态机更复杂</a:t>
+            </a:r>
+          </a:p>
+        </p:txBody>
+      </p:sp>
+      <p:sp>
+        <p:nvSpPr>
+          <p:cNvPr id="16" name="Rounded Rectangle 15"/>
+          <p:cNvSpPr/>
+          <p:nvPr/>
+        </p:nvSpPr>
+        <p:spPr>
+          <a:xfrm>
+            <a:off x="6263640" y="3840480"/>
+            <a:ext cx="5669280" cy="2560320"/>
           </a:xfrm>
           <a:prstGeom prst="roundRect">
             <a:avLst>
@@ -9382,14 +9989,14 @@
       </p:sp>
       <p:sp>
         <p:nvSpPr>
-          <p:cNvPr id="9" name="Rounded Rectangle 8"/>
+          <p:cNvPr id="17" name="Rounded Rectangle 16"/>
           <p:cNvSpPr/>
           <p:nvPr/>
         </p:nvSpPr>
         <p:spPr>
           <a:xfrm>
-            <a:off x="502920" y="3474720"/>
-            <a:ext cx="2011680" cy="292608"/>
+            <a:off x="6428232" y="4005072"/>
+            <a:ext cx="2377440" cy="292608"/>
           </a:xfrm>
           <a:prstGeom prst="roundRect">
             <a:avLst>
@@ -9423,27 +10030,27 @@
           <a:p>
             <a:pPr algn="ctr"/>
             <a:r>
-              <a:rPr sz="1000" b="1">
+              <a:rPr sz="1100" b="1">
                 <a:solidFill>
                   <a:srgbClr val="FFFFFF"/>
                 </a:solidFill>
                 <a:latin typeface="Calibri"/>
               </a:rPr>
-              <a:t>一期默认 ★</a:t>
-            </a:r>
-          </a:p>
-        </p:txBody>
-      </p:sp>
-      <p:sp>
-        <p:nvSpPr>
-          <p:cNvPr id="10" name="TextBox 9"/>
+              <a:t>中台主路径推荐</a:t>
+            </a:r>
+          </a:p>
+        </p:txBody>
+      </p:sp>
+      <p:sp>
+        <p:nvSpPr>
+          <p:cNvPr id="18" name="TextBox 17"/>
           <p:cNvSpPr txBox="1"/>
           <p:nvPr/>
         </p:nvSpPr>
         <p:spPr>
           <a:xfrm>
-            <a:off x="530352" y="3886200"/>
-            <a:ext cx="3383280" cy="2468880"/>
+            <a:off x="6446520" y="4389120"/>
+            <a:ext cx="5303520" cy="1828800"/>
           </a:xfrm>
           <a:prstGeom prst="rect">
             <a:avLst/>
@@ -9457,23 +10064,23 @@
           <a:lstStyle/>
           <a:p>
             <a:r>
-              <a:rPr sz="1400" b="1">
+              <a:rPr sz="1500" b="1">
                 <a:solidFill>
                   <a:srgbClr val="0F172A"/>
                 </a:solidFill>
                 <a:latin typeface="Calibri"/>
               </a:rPr>
-              <a:t>方案 A · 下载后渲染</a:t>
+              <a:t>方案 4 · D 云预览出链接 ★</a:t>
             </a:r>
           </a:p>
           <a:p>
             <a:pPr>
               <a:spcBef>
-                <a:spcPts val="800"/>
+                <a:spcPts val="600"/>
               </a:spcBef>
             </a:pPr>
             <a:r>
-              <a:rPr sz="1100" b="1">
+              <a:rPr sz="1200" b="1">
                 <a:solidFill>
                   <a:srgbClr val="0F766E"/>
                 </a:solidFill>
@@ -9482,48 +10089,48 @@
               <a:t>流程：</a:t>
             </a:r>
             <a:r>
-              <a:rPr sz="1100" b="0">
+              <a:rPr sz="1200" b="0">
                 <a:solidFill>
                   <a:srgbClr val="334155"/>
                 </a:solidFill>
                 <a:latin typeface="Calibri"/>
               </a:rPr>
-              <a:t>write→同步→REST全文→一次加载</a:t>
+              <a:t>发布到预览 Web 服务→返回 URL→WebView 直接打开</a:t>
             </a:r>
           </a:p>
           <a:p>
             <a:pPr>
               <a:spcBef>
-                <a:spcPts val="800"/>
+                <a:spcPts val="600"/>
               </a:spcBef>
             </a:pPr>
             <a:r>
-              <a:rPr sz="1100" b="1">
+              <a:rPr sz="1200" b="1">
                 <a:solidFill>
                   <a:srgbClr val="0F766E"/>
                 </a:solidFill>
                 <a:latin typeface="Calibri"/>
               </a:rPr>
-              <a:t>优势：</a:t>
-            </a:r>
-            <a:r>
-              <a:rPr sz="1100" b="0">
+              <a:t>要点：</a:t>
+            </a:r>
+            <a:r>
+              <a:rPr sz="1200" b="0">
                 <a:solidFill>
                   <a:srgbClr val="334155"/>
                 </a:solidFill>
                 <a:latin typeface="Calibri"/>
               </a:rPr>
-              <a:t>稳、完整、易回放、贴合云空间</a:t>
+              <a:t>端最简；多文件/分享/统一 CSP 天然友好</a:t>
             </a:r>
           </a:p>
           <a:p>
             <a:pPr>
               <a:spcBef>
-                <a:spcPts val="800"/>
+                <a:spcPts val="600"/>
               </a:spcBef>
             </a:pPr>
             <a:r>
-              <a:rPr sz="1100" b="1">
+              <a:rPr sz="1200" b="1">
                 <a:solidFill>
                   <a:srgbClr val="0F766E"/>
                 </a:solidFill>
@@ -9532,433 +10139,13 @@
               <a:t>代价：</a:t>
             </a:r>
             <a:r>
-              <a:rPr sz="1100" b="0">
+              <a:rPr sz="1200" b="0">
                 <a:solidFill>
                   <a:srgbClr val="334155"/>
                 </a:solidFill>
                 <a:latin typeface="Calibri"/>
               </a:rPr>
-              <a:t>需等生成+同步才出首屏</a:t>
-            </a:r>
-          </a:p>
-        </p:txBody>
-      </p:sp>
-      <p:sp>
-        <p:nvSpPr>
-          <p:cNvPr id="11" name="Rounded Rectangle 10"/>
-          <p:cNvSpPr/>
-          <p:nvPr/>
-        </p:nvSpPr>
-        <p:spPr>
-          <a:xfrm>
-            <a:off x="4251960" y="3337560"/>
-            <a:ext cx="3703320" cy="3154680"/>
-          </a:xfrm>
-          <a:prstGeom prst="roundRect">
-            <a:avLst>
-              <a:gd name="adj" fmla="val 8000"/>
-            </a:avLst>
-          </a:prstGeom>
-          <a:solidFill>
-            <a:srgbClr val="FFFFFF"/>
-          </a:solidFill>
-          <a:ln w="12700">
-            <a:solidFill>
-              <a:srgbClr val="64748B"/>
-            </a:solidFill>
-          </a:ln>
-        </p:spPr>
-        <p:style>
-          <a:lnRef idx="1">
-            <a:schemeClr val="accent1"/>
-          </a:lnRef>
-          <a:fillRef idx="3">
-            <a:schemeClr val="accent1"/>
-          </a:fillRef>
-          <a:effectRef idx="2">
-            <a:schemeClr val="accent1"/>
-          </a:effectRef>
-          <a:fontRef idx="minor">
-            <a:schemeClr val="lt1"/>
-          </a:fontRef>
-        </p:style>
-        <p:txBody>
-          <a:bodyPr rtlCol="0" anchor="ctr"/>
-          <a:lstStyle/>
-          <a:p>
-            <a:pPr algn="ctr"/>
-          </a:p>
-        </p:txBody>
-      </p:sp>
-      <p:sp>
-        <p:nvSpPr>
-          <p:cNvPr id="12" name="Rounded Rectangle 11"/>
-          <p:cNvSpPr/>
-          <p:nvPr/>
-        </p:nvSpPr>
-        <p:spPr>
-          <a:xfrm>
-            <a:off x="4389120" y="3474720"/>
-            <a:ext cx="2011680" cy="292608"/>
-          </a:xfrm>
-          <a:prstGeom prst="roundRect">
-            <a:avLst>
-              <a:gd name="adj" fmla="val 40000"/>
-            </a:avLst>
-          </a:prstGeom>
-          <a:solidFill>
-            <a:srgbClr val="64748B"/>
-          </a:solidFill>
-          <a:ln>
-            <a:noFill/>
-          </a:ln>
-        </p:spPr>
-        <p:style>
-          <a:lnRef idx="1">
-            <a:schemeClr val="accent1"/>
-          </a:lnRef>
-          <a:fillRef idx="3">
-            <a:schemeClr val="accent1"/>
-          </a:fillRef>
-          <a:effectRef idx="2">
-            <a:schemeClr val="accent1"/>
-          </a:effectRef>
-          <a:fontRef idx="minor">
-            <a:schemeClr val="lt1"/>
-          </a:fontRef>
-        </p:style>
-        <p:txBody>
-          <a:bodyPr rtlCol="0" anchor="ctr"/>
-          <a:lstStyle/>
-          <a:p>
-            <a:pPr algn="ctr"/>
-            <a:r>
-              <a:rPr sz="1000" b="1">
-                <a:solidFill>
-                  <a:srgbClr val="FFFFFF"/>
-                </a:solidFill>
-                <a:latin typeface="Calibri"/>
-              </a:rPr>
-              <a:t>二期增强</a:t>
-            </a:r>
-          </a:p>
-        </p:txBody>
-      </p:sp>
-      <p:sp>
-        <p:nvSpPr>
-          <p:cNvPr id="13" name="TextBox 12"/>
-          <p:cNvSpPr txBox="1"/>
-          <p:nvPr/>
-        </p:nvSpPr>
-        <p:spPr>
-          <a:xfrm>
-            <a:off x="4416552" y="3886200"/>
-            <a:ext cx="3383280" cy="2468880"/>
-          </a:xfrm>
-          <a:prstGeom prst="rect">
-            <a:avLst/>
-          </a:prstGeom>
-          <a:noFill/>
-        </p:spPr>
-        <p:txBody>
-          <a:bodyPr wrap="square">
-            <a:spAutoFit/>
-          </a:bodyPr>
-          <a:lstStyle/>
-          <a:p>
-            <a:r>
-              <a:rPr sz="1400" b="1">
-                <a:solidFill>
-                  <a:srgbClr val="0F172A"/>
-                </a:solidFill>
-                <a:latin typeface="Calibri"/>
-              </a:rPr>
-              <a:t>方案 B · 流式实时渲染</a:t>
-            </a:r>
-          </a:p>
-          <a:p>
-            <a:pPr>
-              <a:spcBef>
-                <a:spcPts val="800"/>
-              </a:spcBef>
-            </a:pPr>
-            <a:r>
-              <a:rPr sz="1100" b="1">
-                <a:solidFill>
-                  <a:srgbClr val="0F766E"/>
-                </a:solidFill>
-                <a:latin typeface="Calibri"/>
-              </a:rPr>
-              <a:t>流程：</a:t>
-            </a:r>
-            <a:r>
-              <a:rPr sz="1100" b="0">
-                <a:solidFill>
-                  <a:srgbClr val="334155"/>
-                </a:solidFill>
-                <a:latin typeface="Calibri"/>
-              </a:rPr>
-              <a:t>token/delta→buffer→边收边刷新</a:t>
-            </a:r>
-          </a:p>
-          <a:p>
-            <a:pPr>
-              <a:spcBef>
-                <a:spcPts val="800"/>
-              </a:spcBef>
-            </a:pPr>
-            <a:r>
-              <a:rPr sz="1100" b="1">
-                <a:solidFill>
-                  <a:srgbClr val="0F766E"/>
-                </a:solidFill>
-                <a:latin typeface="Calibri"/>
-              </a:rPr>
-              <a:t>优势：</a:t>
-            </a:r>
-            <a:r>
-              <a:rPr sz="1100" b="0">
-                <a:solidFill>
-                  <a:srgbClr val="334155"/>
-                </a:solidFill>
-                <a:latin typeface="Calibri"/>
-              </a:rPr>
-              <a:t>首屏快，体感像流式 Markdown</a:t>
-            </a:r>
-          </a:p>
-          <a:p>
-            <a:pPr>
-              <a:spcBef>
-                <a:spcPts val="800"/>
-              </a:spcBef>
-            </a:pPr>
-            <a:r>
-              <a:rPr sz="1100" b="1">
-                <a:solidFill>
-                  <a:srgbClr val="0F766E"/>
-                </a:solidFill>
-                <a:latin typeface="Calibri"/>
-              </a:rPr>
-              <a:t>代价：</a:t>
-            </a:r>
-            <a:r>
-              <a:rPr sz="1100" b="0">
-                <a:solidFill>
-                  <a:srgbClr val="334155"/>
-                </a:solidFill>
-                <a:latin typeface="Calibri"/>
-              </a:rPr>
-              <a:t>半截标签/脚本重复/协议重</a:t>
-            </a:r>
-          </a:p>
-        </p:txBody>
-      </p:sp>
-      <p:sp>
-        <p:nvSpPr>
-          <p:cNvPr id="14" name="Rounded Rectangle 13"/>
-          <p:cNvSpPr/>
-          <p:nvPr/>
-        </p:nvSpPr>
-        <p:spPr>
-          <a:xfrm>
-            <a:off x="8138160" y="3337560"/>
-            <a:ext cx="3703320" cy="3154680"/>
-          </a:xfrm>
-          <a:prstGeom prst="roundRect">
-            <a:avLst>
-              <a:gd name="adj" fmla="val 8000"/>
-            </a:avLst>
-          </a:prstGeom>
-          <a:solidFill>
-            <a:srgbClr val="F0FDFA"/>
-          </a:solidFill>
-          <a:ln w="12700">
-            <a:solidFill>
-              <a:srgbClr val="0F766E"/>
-            </a:solidFill>
-          </a:ln>
-        </p:spPr>
-        <p:style>
-          <a:lnRef idx="1">
-            <a:schemeClr val="accent1"/>
-          </a:lnRef>
-          <a:fillRef idx="3">
-            <a:schemeClr val="accent1"/>
-          </a:fillRef>
-          <a:effectRef idx="2">
-            <a:schemeClr val="accent1"/>
-          </a:effectRef>
-          <a:fontRef idx="minor">
-            <a:schemeClr val="lt1"/>
-          </a:fontRef>
-        </p:style>
-        <p:txBody>
-          <a:bodyPr rtlCol="0" anchor="ctr"/>
-          <a:lstStyle/>
-          <a:p>
-            <a:pPr algn="ctr"/>
-          </a:p>
-        </p:txBody>
-      </p:sp>
-      <p:sp>
-        <p:nvSpPr>
-          <p:cNvPr id="15" name="Rounded Rectangle 14"/>
-          <p:cNvSpPr/>
-          <p:nvPr/>
-        </p:nvSpPr>
-        <p:spPr>
-          <a:xfrm>
-            <a:off x="8275320" y="3474720"/>
-            <a:ext cx="2011680" cy="292608"/>
-          </a:xfrm>
-          <a:prstGeom prst="roundRect">
-            <a:avLst>
-              <a:gd name="adj" fmla="val 40000"/>
-            </a:avLst>
-          </a:prstGeom>
-          <a:solidFill>
-            <a:srgbClr val="0F766E"/>
-          </a:solidFill>
-          <a:ln>
-            <a:noFill/>
-          </a:ln>
-        </p:spPr>
-        <p:style>
-          <a:lnRef idx="1">
-            <a:schemeClr val="accent1"/>
-          </a:lnRef>
-          <a:fillRef idx="3">
-            <a:schemeClr val="accent1"/>
-          </a:fillRef>
-          <a:effectRef idx="2">
-            <a:schemeClr val="accent1"/>
-          </a:effectRef>
-          <a:fontRef idx="minor">
-            <a:schemeClr val="lt1"/>
-          </a:fontRef>
-        </p:style>
-        <p:txBody>
-          <a:bodyPr rtlCol="0" anchor="ctr"/>
-          <a:lstStyle/>
-          <a:p>
-            <a:pPr algn="ctr"/>
-            <a:r>
-              <a:rPr sz="1000" b="1">
-                <a:solidFill>
-                  <a:srgbClr val="FFFFFF"/>
-                </a:solidFill>
-                <a:latin typeface="Calibri"/>
-              </a:rPr>
-              <a:t>报告场景演进 ★</a:t>
-            </a:r>
-          </a:p>
-        </p:txBody>
-      </p:sp>
-      <p:sp>
-        <p:nvSpPr>
-          <p:cNvPr id="16" name="TextBox 15"/>
-          <p:cNvSpPr txBox="1"/>
-          <p:nvPr/>
-        </p:nvSpPr>
-        <p:spPr>
-          <a:xfrm>
-            <a:off x="8302752" y="3886200"/>
-            <a:ext cx="3383280" cy="2468880"/>
-          </a:xfrm>
-          <a:prstGeom prst="rect">
-            <a:avLst/>
-          </a:prstGeom>
-          <a:noFill/>
-        </p:spPr>
-        <p:txBody>
-          <a:bodyPr wrap="square">
-            <a:spAutoFit/>
-          </a:bodyPr>
-          <a:lstStyle/>
-          <a:p>
-            <a:r>
-              <a:rPr sz="1400" b="1">
-                <a:solidFill>
-                  <a:srgbClr val="0F172A"/>
-                </a:solidFill>
-                <a:latin typeface="Calibri"/>
-              </a:rPr>
-              <a:t>方案 C · 混合</a:t>
-            </a:r>
-          </a:p>
-          <a:p>
-            <a:pPr>
-              <a:spcBef>
-                <a:spcPts val="800"/>
-              </a:spcBef>
-            </a:pPr>
-            <a:r>
-              <a:rPr sz="1100" b="1">
-                <a:solidFill>
-                  <a:srgbClr val="0F766E"/>
-                </a:solidFill>
-                <a:latin typeface="Calibri"/>
-              </a:rPr>
-              <a:t>流程：</a:t>
-            </a:r>
-            <a:r>
-              <a:rPr sz="1100" b="0">
-                <a:solidFill>
-                  <a:srgbClr val="334155"/>
-                </a:solidFill>
-                <a:latin typeface="Calibri"/>
-              </a:rPr>
-              <a:t>流式粗预览 + 完成后 write 定稿</a:t>
-            </a:r>
-          </a:p>
-          <a:p>
-            <a:pPr>
-              <a:spcBef>
-                <a:spcPts val="800"/>
-              </a:spcBef>
-            </a:pPr>
-            <a:r>
-              <a:rPr sz="1100" b="1">
-                <a:solidFill>
-                  <a:srgbClr val="0F766E"/>
-                </a:solidFill>
-                <a:latin typeface="Calibri"/>
-              </a:rPr>
-              <a:t>优势：</a:t>
-            </a:r>
-            <a:r>
-              <a:rPr sz="1100" b="0">
-                <a:solidFill>
-                  <a:srgbClr val="334155"/>
-                </a:solidFill>
-                <a:latin typeface="Calibri"/>
-              </a:rPr>
-              <a:t>体验近 B，正确性兜底靠 A</a:t>
-            </a:r>
-          </a:p>
-          <a:p>
-            <a:pPr>
-              <a:spcBef>
-                <a:spcPts val="800"/>
-              </a:spcBef>
-            </a:pPr>
-            <a:r>
-              <a:rPr sz="1100" b="1">
-                <a:solidFill>
-                  <a:srgbClr val="0F766E"/>
-                </a:solidFill>
-                <a:latin typeface="Calibri"/>
-              </a:rPr>
-              <a:t>代价：</a:t>
-            </a:r>
-            <a:r>
-              <a:rPr sz="1100" b="0">
-                <a:solidFill>
-                  <a:srgbClr val="334155"/>
-                </a:solidFill>
-                <a:latin typeface="Calibri"/>
-              </a:rPr>
-              <a:t>状态机更复杂，需切换策略</a:t>
+              <a:t>需养预览域（或存储签名 URL 网关）</a:t>
             </a:r>
           </a:p>
         </p:txBody>
@@ -10159,7 +10346,7 @@
                 </a:solidFill>
                 <a:latin typeface="Calibri"/>
               </a:rPr>
-              <a:t>06</a:t>
+              <a:t>05b</a:t>
             </a:r>
           </a:p>
         </p:txBody>
@@ -10193,7 +10380,7 @@
                 </a:solidFill>
                 <a:latin typeface="Calibri"/>
               </a:rPr>
-              <a:t>实现示例</a:t>
+              <a:t>方案 4 详解：云预览服务 → 可渲染链接</a:t>
             </a:r>
           </a:p>
           <a:p>
@@ -10204,21 +10391,206 @@
                 </a:solidFill>
                 <a:latin typeface="Calibri"/>
               </a:rPr>
-              <a:t>健康报告闭环：契约 · 方案 A · 方案 C</a:t>
-            </a:r>
-          </a:p>
-        </p:txBody>
-      </p:sp>
-      <p:sp>
-        <p:nvSpPr>
-          <p:cNvPr id="7" name="Rounded Rectangle 6"/>
+              <a:t>专用（或轻量）HTTP 入口，供 WebView / iframe 直接 loadUrl</a:t>
+            </a:r>
+          </a:p>
+        </p:txBody>
+      </p:sp>
+      <p:pic>
+        <p:nvPicPr>
+          <p:cNvPr id="7" name="Picture 6" descr="ppt-scheme-preview-url.png"/>
+          <p:cNvPicPr>
+            <a:picLocks noChangeAspect="1"/>
+          </p:cNvPicPr>
+          <p:nvPr/>
+        </p:nvPicPr>
+        <p:blipFill>
+          <a:blip r:embed="rId2"/>
+          <a:stretch>
+            <a:fillRect/>
+          </a:stretch>
+        </p:blipFill>
+        <p:spPr>
+          <a:xfrm>
+            <a:off x="365760" y="1097280"/>
+            <a:ext cx="6766560" cy="3200400"/>
+          </a:xfrm>
+          <a:prstGeom prst="rect">
+            <a:avLst/>
+          </a:prstGeom>
+        </p:spPr>
+      </p:pic>
+      <p:sp>
+        <p:nvSpPr>
+          <p:cNvPr id="8" name="Rounded Rectangle 7"/>
           <p:cNvSpPr/>
           <p:nvPr/>
         </p:nvSpPr>
         <p:spPr>
           <a:xfrm>
-            <a:off x="320040" y="1097280"/>
-            <a:ext cx="4114800" cy="5394960"/>
+            <a:off x="7315200" y="1097280"/>
+            <a:ext cx="4480560" cy="3200400"/>
+          </a:xfrm>
+          <a:prstGeom prst="roundRect">
+            <a:avLst>
+              <a:gd name="adj" fmla="val 8000"/>
+            </a:avLst>
+          </a:prstGeom>
+          <a:solidFill>
+            <a:srgbClr val="F0FDFA"/>
+          </a:solidFill>
+          <a:ln w="12700">
+            <a:solidFill>
+              <a:srgbClr val="0D9488"/>
+            </a:solidFill>
+          </a:ln>
+        </p:spPr>
+        <p:style>
+          <a:lnRef idx="1">
+            <a:schemeClr val="accent1"/>
+          </a:lnRef>
+          <a:fillRef idx="3">
+            <a:schemeClr val="accent1"/>
+          </a:fillRef>
+          <a:effectRef idx="2">
+            <a:schemeClr val="accent1"/>
+          </a:effectRef>
+          <a:fontRef idx="minor">
+            <a:schemeClr val="lt1"/>
+          </a:fontRef>
+        </p:style>
+        <p:txBody>
+          <a:bodyPr rtlCol="0" anchor="ctr"/>
+          <a:lstStyle/>
+          <a:p>
+            <a:pPr algn="ctr"/>
+          </a:p>
+        </p:txBody>
+      </p:sp>
+      <p:sp>
+        <p:nvSpPr>
+          <p:cNvPr id="9" name="TextBox 8"/>
+          <p:cNvSpPr txBox="1"/>
+          <p:nvPr/>
+        </p:nvSpPr>
+        <p:spPr>
+          <a:xfrm>
+            <a:off x="7498079" y="1234440"/>
+            <a:ext cx="4160520" cy="2926080"/>
+          </a:xfrm>
+          <a:prstGeom prst="rect">
+            <a:avLst/>
+          </a:prstGeom>
+          <a:noFill/>
+        </p:spPr>
+        <p:txBody>
+          <a:bodyPr wrap="square">
+            <a:spAutoFit/>
+          </a:bodyPr>
+          <a:lstStyle/>
+          <a:p>
+            <a:r>
+              <a:rPr sz="1400" b="1">
+                <a:solidFill>
+                  <a:srgbClr val="0D9488"/>
+                </a:solidFill>
+                <a:latin typeface="Calibri"/>
+              </a:rPr>
+              <a:t>核心链路</a:t>
+            </a:r>
+          </a:p>
+          <a:p>
+            <a:pPr>
+              <a:spcBef>
+                <a:spcPts val="600"/>
+              </a:spcBef>
+            </a:pPr>
+            <a:r>
+              <a:rPr sz="1200" b="0">
+                <a:solidFill>
+                  <a:srgbClr val="334155"/>
+                </a:solidFill>
+                <a:latin typeface="Calibri"/>
+              </a:rPr>
+              <a:t>1. Agent 生成 HTML（可 write 到云空间）</a:t>
+            </a:r>
+          </a:p>
+          <a:p>
+            <a:pPr>
+              <a:spcBef>
+                <a:spcPts val="600"/>
+              </a:spcBef>
+            </a:pPr>
+            <a:r>
+              <a:rPr sz="1200" b="0">
+                <a:solidFill>
+                  <a:srgbClr val="334155"/>
+                </a:solidFill>
+                <a:latin typeface="Calibri"/>
+              </a:rPr>
+              <a:t>2. 发布到预览 Web 服务 / 签名托管</a:t>
+            </a:r>
+          </a:p>
+          <a:p>
+            <a:pPr>
+              <a:spcBef>
+                <a:spcPts val="600"/>
+              </a:spcBef>
+            </a:pPr>
+            <a:r>
+              <a:rPr sz="1200" b="0">
+                <a:solidFill>
+                  <a:srgbClr val="334155"/>
+                </a:solidFill>
+                <a:latin typeface="Calibri"/>
+              </a:rPr>
+              <a:t>3. 返回 https://preview…/p/{id}/</a:t>
+            </a:r>
+          </a:p>
+          <a:p>
+            <a:pPr>
+              <a:spcBef>
+                <a:spcPts val="600"/>
+              </a:spcBef>
+            </a:pPr>
+            <a:r>
+              <a:rPr sz="1200" b="0">
+                <a:solidFill>
+                  <a:srgbClr val="334155"/>
+                </a:solidFill>
+                <a:latin typeface="Calibri"/>
+              </a:rPr>
+              <a:t>4. 端 WebView.loadUrl(link)</a:t>
+            </a:r>
+          </a:p>
+          <a:p>
+            <a:pPr>
+              <a:spcBef>
+                <a:spcPts val="600"/>
+              </a:spcBef>
+            </a:pPr>
+            <a:r>
+              <a:rPr sz="1200" b="0">
+                <a:solidFill>
+                  <a:srgbClr val="334155"/>
+                </a:solidFill>
+                <a:latin typeface="Calibri"/>
+              </a:rPr>
+              <a:t>5. 服务保证 text/html + CSP/TTL</a:t>
+            </a:r>
+          </a:p>
+        </p:txBody>
+      </p:sp>
+      <p:sp>
+        <p:nvSpPr>
+          <p:cNvPr id="10" name="Rounded Rectangle 9"/>
+          <p:cNvSpPr/>
+          <p:nvPr/>
+        </p:nvSpPr>
+        <p:spPr>
+          <a:xfrm>
+            <a:off x="365760" y="4480560"/>
+            <a:ext cx="3703320" cy="2011680"/>
           </a:xfrm>
           <a:prstGeom prst="roundRect">
             <a:avLst>
@@ -10258,14 +10630,14 @@
       </p:sp>
       <p:sp>
         <p:nvSpPr>
-          <p:cNvPr id="8" name="TextBox 7"/>
+          <p:cNvPr id="11" name="TextBox 10"/>
           <p:cNvSpPr txBox="1"/>
           <p:nvPr/>
         </p:nvSpPr>
         <p:spPr>
           <a:xfrm>
-            <a:off x="457200" y="1234440"/>
-            <a:ext cx="3840480" cy="365760"/>
+            <a:off x="548640" y="4617720"/>
+            <a:ext cx="3383280" cy="1737360"/>
           </a:xfrm>
           <a:prstGeom prst="rect">
             <a:avLst/>
@@ -10279,36 +10651,72 @@
           <a:lstStyle/>
           <a:p>
             <a:r>
-              <a:rPr sz="1400" b="1">
+              <a:rPr sz="1300" b="1">
                 <a:solidFill>
                   <a:srgbClr val="0D9488"/>
                 </a:solidFill>
                 <a:latin typeface="Calibri"/>
               </a:rPr>
-              <a:t>健康报告串接</a:t>
-            </a:r>
-          </a:p>
-        </p:txBody>
-      </p:sp>
-      <p:sp>
-        <p:nvSpPr>
-          <p:cNvPr id="9" name="Oval 8"/>
+              <a:t>端侧</a:t>
+            </a:r>
+          </a:p>
+          <a:p>
+            <a:pPr>
+              <a:spcBef>
+                <a:spcPts val="400"/>
+              </a:spcBef>
+            </a:pPr>
+            <a:r>
+              <a:rPr sz="1200" b="0">
+                <a:solidFill>
+                  <a:srgbClr val="334155"/>
+                </a:solidFill>
+                <a:latin typeface="Calibri"/>
+              </a:rPr>
+              <a:t>不再必须 REST 拉全文再 srcdoc；</a:t>
+            </a:r>
+          </a:p>
+          <a:p>
+            <a:pPr>
+              <a:spcBef>
+                <a:spcPts val="400"/>
+              </a:spcBef>
+            </a:pPr>
+            <a:r>
+              <a:rPr sz="1200" b="0">
+                <a:solidFill>
+                  <a:srgbClr val="334155"/>
+                </a:solidFill>
+                <a:latin typeface="Calibri"/>
+              </a:rPr>
+              <a:t>Web / 原生统一 loadUrl</a:t>
+            </a:r>
+          </a:p>
+        </p:txBody>
+      </p:sp>
+      <p:sp>
+        <p:nvSpPr>
+          <p:cNvPr id="12" name="Rounded Rectangle 11"/>
           <p:cNvSpPr/>
           <p:nvPr/>
         </p:nvSpPr>
         <p:spPr>
           <a:xfrm>
-            <a:off x="548640" y="1737360"/>
-            <a:ext cx="384048" cy="384048"/>
-          </a:xfrm>
-          <a:prstGeom prst="ellipse">
-            <a:avLst/>
+            <a:off x="4251960" y="4480560"/>
+            <a:ext cx="3703320" cy="2011680"/>
+          </a:xfrm>
+          <a:prstGeom prst="roundRect">
+            <a:avLst>
+              <a:gd name="adj" fmla="val 8000"/>
+            </a:avLst>
           </a:prstGeom>
           <a:solidFill>
-            <a:srgbClr val="0D9488"/>
+            <a:srgbClr val="FFFFFF"/>
           </a:solidFill>
-          <a:ln>
-            <a:noFill/>
+          <a:ln w="12700">
+            <a:solidFill>
+              <a:srgbClr val="E2E8F0"/>
+            </a:solidFill>
           </a:ln>
         </p:spPr>
         <p:style>
@@ -10330,28 +10738,19 @@
           <a:lstStyle/>
           <a:p>
             <a:pPr algn="ctr"/>
-            <a:r>
-              <a:rPr sz="1200" b="1">
-                <a:solidFill>
-                  <a:srgbClr val="FFFFFF"/>
-                </a:solidFill>
-                <a:latin typeface="Calibri"/>
-              </a:rPr>
-              <a:t>1</a:t>
-            </a:r>
-          </a:p>
-        </p:txBody>
-      </p:sp>
-      <p:sp>
-        <p:nvSpPr>
-          <p:cNvPr id="10" name="TextBox 9"/>
+          </a:p>
+        </p:txBody>
+      </p:sp>
+      <p:sp>
+        <p:nvSpPr>
+          <p:cNvPr id="13" name="TextBox 12"/>
           <p:cNvSpPr txBox="1"/>
           <p:nvPr/>
         </p:nvSpPr>
         <p:spPr>
           <a:xfrm>
-            <a:off x="1097280" y="1691640"/>
-            <a:ext cx="3108960" cy="731520"/>
+            <a:off x="4434840" y="4617720"/>
+            <a:ext cx="3383280" cy="1737360"/>
           </a:xfrm>
           <a:prstGeom prst="rect">
             <a:avLst/>
@@ -10365,36 +10764,72 @@
           <a:lstStyle/>
           <a:p>
             <a:r>
+              <a:rPr sz="1300" b="1">
+                <a:solidFill>
+                  <a:srgbClr val="0D9488"/>
+                </a:solidFill>
+                <a:latin typeface="Calibri"/>
+              </a:rPr>
+              <a:t>云侧</a:t>
+            </a:r>
+          </a:p>
+          <a:p>
+            <a:pPr>
+              <a:spcBef>
+                <a:spcPts val="400"/>
+              </a:spcBef>
+            </a:pPr>
+            <a:r>
               <a:rPr sz="1200" b="0">
                 <a:solidFill>
                   <a:srgbClr val="334155"/>
                 </a:solidFill>
                 <a:latin typeface="Calibri"/>
               </a:rPr>
-              <a:t>Skill 拉取运动健康数据</a:t>
-            </a:r>
-          </a:p>
-        </p:txBody>
-      </p:sp>
-      <p:sp>
-        <p:nvSpPr>
-          <p:cNvPr id="11" name="Oval 10"/>
+              <a:t>统一承载所有 Web 预览需求；</a:t>
+            </a:r>
+          </a:p>
+          <a:p>
+            <a:pPr>
+              <a:spcBef>
+                <a:spcPts val="400"/>
+              </a:spcBef>
+            </a:pPr>
+            <a:r>
+              <a:rPr sz="1200" b="0">
+                <a:solidFill>
+                  <a:srgbClr val="334155"/>
+                </a:solidFill>
+                <a:latin typeface="Calibri"/>
+              </a:rPr>
+              <a:t>多文件相对路径自然支持</a:t>
+            </a:r>
+          </a:p>
+        </p:txBody>
+      </p:sp>
+      <p:sp>
+        <p:nvSpPr>
+          <p:cNvPr id="14" name="Rounded Rectangle 13"/>
           <p:cNvSpPr/>
           <p:nvPr/>
         </p:nvSpPr>
         <p:spPr>
           <a:xfrm>
-            <a:off x="548640" y="2606040"/>
-            <a:ext cx="384048" cy="384048"/>
-          </a:xfrm>
-          <a:prstGeom prst="ellipse">
-            <a:avLst/>
+            <a:off x="8138160" y="4480560"/>
+            <a:ext cx="3703320" cy="2011680"/>
+          </a:xfrm>
+          <a:prstGeom prst="roundRect">
+            <a:avLst>
+              <a:gd name="adj" fmla="val 8000"/>
+            </a:avLst>
           </a:prstGeom>
           <a:solidFill>
-            <a:srgbClr val="0D9488"/>
+            <a:srgbClr val="FFFFFF"/>
           </a:solidFill>
-          <a:ln>
-            <a:noFill/>
+          <a:ln w="12700">
+            <a:solidFill>
+              <a:srgbClr val="E2E8F0"/>
+            </a:solidFill>
           </a:ln>
         </p:spPr>
         <p:style>
@@ -10416,28 +10851,19 @@
           <a:lstStyle/>
           <a:p>
             <a:pPr algn="ctr"/>
-            <a:r>
-              <a:rPr sz="1200" b="1">
-                <a:solidFill>
-                  <a:srgbClr val="FFFFFF"/>
-                </a:solidFill>
-                <a:latin typeface="Calibri"/>
-              </a:rPr>
-              <a:t>2</a:t>
-            </a:r>
-          </a:p>
-        </p:txBody>
-      </p:sp>
-      <p:sp>
-        <p:nvSpPr>
-          <p:cNvPr id="12" name="TextBox 11"/>
+          </a:p>
+        </p:txBody>
+      </p:sp>
+      <p:sp>
+        <p:nvSpPr>
+          <p:cNvPr id="15" name="TextBox 14"/>
           <p:cNvSpPr txBox="1"/>
           <p:nvPr/>
         </p:nvSpPr>
         <p:spPr>
           <a:xfrm>
-            <a:off x="1097280" y="2560320"/>
-            <a:ext cx="3108960" cy="731520"/>
+            <a:off x="8321040" y="4617720"/>
+            <a:ext cx="3383280" cy="1737360"/>
           </a:xfrm>
           <a:prstGeom prst="rect">
             <a:avLst/>
@@ -10451,16 +10877,37 @@
           <a:lstStyle/>
           <a:p>
             <a:r>
+              <a:rPr sz="1300" b="1">
+                <a:solidFill>
+                  <a:srgbClr val="0D9488"/>
+                </a:solidFill>
+                <a:latin typeface="Calibri"/>
+              </a:rPr>
+              <a:t>与云空间关系</a:t>
+            </a:r>
+          </a:p>
+          <a:p>
+            <a:pPr>
+              <a:spcBef>
+                <a:spcPts val="400"/>
+              </a:spcBef>
+            </a:pPr>
+            <a:r>
               <a:rPr sz="1200" b="0">
                 <a:solidFill>
                   <a:srgbClr val="334155"/>
                 </a:solidFill>
                 <a:latin typeface="Calibri"/>
               </a:rPr>
-              <a:t>生成单文件图表 HTML</a:t>
-            </a:r>
-          </a:p>
-          <a:p>
+              <a:t>云空间可作源文件仓；</a:t>
+            </a:r>
+          </a:p>
+          <a:p>
+            <a:pPr>
+              <a:spcBef>
+                <a:spcPts val="400"/>
+              </a:spcBef>
+            </a:pPr>
             <a:r>
               <a:rPr sz="1200" b="0">
                 <a:solidFill>
@@ -10468,651 +10915,7 @@
                 </a:solidFill>
                 <a:latin typeface="Calibri"/>
               </a:rPr>
-              <a:t>（CSS/JS 尽量内联）</a:t>
-            </a:r>
-          </a:p>
-        </p:txBody>
-      </p:sp>
-      <p:sp>
-        <p:nvSpPr>
-          <p:cNvPr id="13" name="Oval 12"/>
-          <p:cNvSpPr/>
-          <p:nvPr/>
-        </p:nvSpPr>
-        <p:spPr>
-          <a:xfrm>
-            <a:off x="548640" y="3474720"/>
-            <a:ext cx="384048" cy="384048"/>
-          </a:xfrm>
-          <a:prstGeom prst="ellipse">
-            <a:avLst/>
-          </a:prstGeom>
-          <a:solidFill>
-            <a:srgbClr val="0D9488"/>
-          </a:solidFill>
-          <a:ln>
-            <a:noFill/>
-          </a:ln>
-        </p:spPr>
-        <p:style>
-          <a:lnRef idx="1">
-            <a:schemeClr val="accent1"/>
-          </a:lnRef>
-          <a:fillRef idx="3">
-            <a:schemeClr val="accent1"/>
-          </a:fillRef>
-          <a:effectRef idx="2">
-            <a:schemeClr val="accent1"/>
-          </a:effectRef>
-          <a:fontRef idx="minor">
-            <a:schemeClr val="lt1"/>
-          </a:fontRef>
-        </p:style>
-        <p:txBody>
-          <a:bodyPr rtlCol="0" anchor="ctr"/>
-          <a:lstStyle/>
-          <a:p>
-            <a:pPr algn="ctr"/>
-            <a:r>
-              <a:rPr sz="1200" b="1">
-                <a:solidFill>
-                  <a:srgbClr val="FFFFFF"/>
-                </a:solidFill>
-                <a:latin typeface="Calibri"/>
-              </a:rPr>
-              <a:t>3</a:t>
-            </a:r>
-          </a:p>
-        </p:txBody>
-      </p:sp>
-      <p:sp>
-        <p:nvSpPr>
-          <p:cNvPr id="14" name="TextBox 13"/>
-          <p:cNvSpPr txBox="1"/>
-          <p:nvPr/>
-        </p:nvSpPr>
-        <p:spPr>
-          <a:xfrm>
-            <a:off x="1097280" y="3429000"/>
-            <a:ext cx="3108960" cy="731520"/>
-          </a:xfrm>
-          <a:prstGeom prst="rect">
-            <a:avLst/>
-          </a:prstGeom>
-          <a:noFill/>
-        </p:spPr>
-        <p:txBody>
-          <a:bodyPr wrap="square">
-            <a:spAutoFit/>
-          </a:bodyPr>
-          <a:lstStyle/>
-          <a:p>
-            <a:r>
-              <a:rPr sz="1200" b="0">
-                <a:solidFill>
-                  <a:srgbClr val="334155"/>
-                </a:solidFill>
-                <a:latin typeface="Calibri"/>
-              </a:rPr>
-              <a:t>write → 云空间同步就绪</a:t>
-            </a:r>
-          </a:p>
-        </p:txBody>
-      </p:sp>
-      <p:sp>
-        <p:nvSpPr>
-          <p:cNvPr id="15" name="Oval 14"/>
-          <p:cNvSpPr/>
-          <p:nvPr/>
-        </p:nvSpPr>
-        <p:spPr>
-          <a:xfrm>
-            <a:off x="548640" y="4343399"/>
-            <a:ext cx="384048" cy="384048"/>
-          </a:xfrm>
-          <a:prstGeom prst="ellipse">
-            <a:avLst/>
-          </a:prstGeom>
-          <a:solidFill>
-            <a:srgbClr val="0D9488"/>
-          </a:solidFill>
-          <a:ln>
-            <a:noFill/>
-          </a:ln>
-        </p:spPr>
-        <p:style>
-          <a:lnRef idx="1">
-            <a:schemeClr val="accent1"/>
-          </a:lnRef>
-          <a:fillRef idx="3">
-            <a:schemeClr val="accent1"/>
-          </a:fillRef>
-          <a:effectRef idx="2">
-            <a:schemeClr val="accent1"/>
-          </a:effectRef>
-          <a:fontRef idx="minor">
-            <a:schemeClr val="lt1"/>
-          </a:fontRef>
-        </p:style>
-        <p:txBody>
-          <a:bodyPr rtlCol="0" anchor="ctr"/>
-          <a:lstStyle/>
-          <a:p>
-            <a:pPr algn="ctr"/>
-            <a:r>
-              <a:rPr sz="1200" b="1">
-                <a:solidFill>
-                  <a:srgbClr val="FFFFFF"/>
-                </a:solidFill>
-                <a:latin typeface="Calibri"/>
-              </a:rPr>
-              <a:t>4</a:t>
-            </a:r>
-          </a:p>
-        </p:txBody>
-      </p:sp>
-      <p:sp>
-        <p:nvSpPr>
-          <p:cNvPr id="16" name="TextBox 15"/>
-          <p:cNvSpPr txBox="1"/>
-          <p:nvPr/>
-        </p:nvSpPr>
-        <p:spPr>
-          <a:xfrm>
-            <a:off x="1097280" y="4297679"/>
-            <a:ext cx="3108960" cy="731520"/>
-          </a:xfrm>
-          <a:prstGeom prst="rect">
-            <a:avLst/>
-          </a:prstGeom>
-          <a:noFill/>
-        </p:spPr>
-        <p:txBody>
-          <a:bodyPr wrap="square">
-            <a:spAutoFit/>
-          </a:bodyPr>
-          <a:lstStyle/>
-          <a:p>
-            <a:r>
-              <a:rPr sz="1200" b="0">
-                <a:solidFill>
-                  <a:srgbClr val="334155"/>
-                </a:solidFill>
-                <a:latin typeface="Calibri"/>
-              </a:rPr>
-              <a:t>端识别 preview.kind=html</a:t>
-            </a:r>
-          </a:p>
-        </p:txBody>
-      </p:sp>
-      <p:sp>
-        <p:nvSpPr>
-          <p:cNvPr id="17" name="Oval 16"/>
-          <p:cNvSpPr/>
-          <p:nvPr/>
-        </p:nvSpPr>
-        <p:spPr>
-          <a:xfrm>
-            <a:off x="548640" y="5212080"/>
-            <a:ext cx="384048" cy="384048"/>
-          </a:xfrm>
-          <a:prstGeom prst="ellipse">
-            <a:avLst/>
-          </a:prstGeom>
-          <a:solidFill>
-            <a:srgbClr val="0D9488"/>
-          </a:solidFill>
-          <a:ln>
-            <a:noFill/>
-          </a:ln>
-        </p:spPr>
-        <p:style>
-          <a:lnRef idx="1">
-            <a:schemeClr val="accent1"/>
-          </a:lnRef>
-          <a:fillRef idx="3">
-            <a:schemeClr val="accent1"/>
-          </a:fillRef>
-          <a:effectRef idx="2">
-            <a:schemeClr val="accent1"/>
-          </a:effectRef>
-          <a:fontRef idx="minor">
-            <a:schemeClr val="lt1"/>
-          </a:fontRef>
-        </p:style>
-        <p:txBody>
-          <a:bodyPr rtlCol="0" anchor="ctr"/>
-          <a:lstStyle/>
-          <a:p>
-            <a:pPr algn="ctr"/>
-            <a:r>
-              <a:rPr sz="1200" b="1">
-                <a:solidFill>
-                  <a:srgbClr val="FFFFFF"/>
-                </a:solidFill>
-                <a:latin typeface="Calibri"/>
-              </a:rPr>
-              <a:t>5</a:t>
-            </a:r>
-          </a:p>
-        </p:txBody>
-      </p:sp>
-      <p:sp>
-        <p:nvSpPr>
-          <p:cNvPr id="18" name="TextBox 17"/>
-          <p:cNvSpPr txBox="1"/>
-          <p:nvPr/>
-        </p:nvSpPr>
-        <p:spPr>
-          <a:xfrm>
-            <a:off x="1097280" y="5166360"/>
-            <a:ext cx="3108960" cy="731520"/>
-          </a:xfrm>
-          <a:prstGeom prst="rect">
-            <a:avLst/>
-          </a:prstGeom>
-          <a:noFill/>
-        </p:spPr>
-        <p:txBody>
-          <a:bodyPr wrap="square">
-            <a:spAutoFit/>
-          </a:bodyPr>
-          <a:lstStyle/>
-          <a:p>
-            <a:r>
-              <a:rPr sz="1200" b="0">
-                <a:solidFill>
-                  <a:srgbClr val="334155"/>
-                </a:solidFill>
-                <a:latin typeface="Calibri"/>
-              </a:rPr>
-              <a:t>sandbox 预览 / 可交互</a:t>
-            </a:r>
-          </a:p>
-        </p:txBody>
-      </p:sp>
-      <p:sp>
-        <p:nvSpPr>
-          <p:cNvPr id="19" name="Rounded Rectangle 18"/>
-          <p:cNvSpPr/>
-          <p:nvPr/>
-        </p:nvSpPr>
-        <p:spPr>
-          <a:xfrm>
-            <a:off x="4617720" y="1097280"/>
-            <a:ext cx="7178040" cy="2331720"/>
-          </a:xfrm>
-          <a:prstGeom prst="roundRect">
-            <a:avLst>
-              <a:gd name="adj" fmla="val 8000"/>
-            </a:avLst>
-          </a:prstGeom>
-          <a:solidFill>
-            <a:srgbClr val="0F172A"/>
-          </a:solidFill>
-          <a:ln w="12700">
-            <a:solidFill>
-              <a:srgbClr val="0F172A"/>
-            </a:solidFill>
-          </a:ln>
-        </p:spPr>
-        <p:style>
-          <a:lnRef idx="1">
-            <a:schemeClr val="accent1"/>
-          </a:lnRef>
-          <a:fillRef idx="3">
-            <a:schemeClr val="accent1"/>
-          </a:fillRef>
-          <a:effectRef idx="2">
-            <a:schemeClr val="accent1"/>
-          </a:effectRef>
-          <a:fontRef idx="minor">
-            <a:schemeClr val="lt1"/>
-          </a:fontRef>
-        </p:style>
-        <p:txBody>
-          <a:bodyPr rtlCol="0" anchor="ctr"/>
-          <a:lstStyle/>
-          <a:p>
-            <a:pPr algn="ctr"/>
-          </a:p>
-        </p:txBody>
-      </p:sp>
-      <p:sp>
-        <p:nvSpPr>
-          <p:cNvPr id="20" name="TextBox 19"/>
-          <p:cNvSpPr txBox="1"/>
-          <p:nvPr/>
-        </p:nvSpPr>
-        <p:spPr>
-          <a:xfrm>
-            <a:off x="4800600" y="1234440"/>
-            <a:ext cx="6858000" cy="2057400"/>
-          </a:xfrm>
-          <a:prstGeom prst="rect">
-            <a:avLst/>
-          </a:prstGeom>
-          <a:noFill/>
-        </p:spPr>
-        <p:txBody>
-          <a:bodyPr wrap="square">
-            <a:spAutoFit/>
-          </a:bodyPr>
-          <a:lstStyle/>
-          <a:p>
-            <a:r>
-              <a:rPr sz="1200" b="0">
-                <a:solidFill>
-                  <a:srgbClr val="5EEAD4"/>
-                </a:solidFill>
-                <a:latin typeface="Consolas"/>
-              </a:rPr>
-              <a:t>// write / 同步完成后的返回（示意）</a:t>
-            </a:r>
-          </a:p>
-          <a:p>
-            <a:r>
-              <a:rPr sz="1200" b="0">
-                <a:solidFill>
-                  <a:srgbClr val="CBD5E1"/>
-                </a:solidFill>
-                <a:latin typeface="Consolas"/>
-              </a:rPr>
-              <a:t>{ "path": "artifacts/health-report.html",</a:t>
-            </a:r>
-          </a:p>
-          <a:p>
-            <a:r>
-              <a:rPr sz="1200" b="0">
-                <a:solidFill>
-                  <a:srgbClr val="CBD5E1"/>
-                </a:solidFill>
-                <a:latin typeface="Consolas"/>
-              </a:rPr>
-              <a:t>  "cloud_file_id": "f_xxx", "mime": "text/html",</a:t>
-            </a:r>
-          </a:p>
-          <a:p>
-            <a:r>
-              <a:rPr sz="1200" b="0">
-                <a:solidFill>
-                  <a:srgbClr val="CBD5E1"/>
-                </a:solidFill>
-                <a:latin typeface="Consolas"/>
-              </a:rPr>
-              <a:t>  "sync_status": "synced",</a:t>
-            </a:r>
-          </a:p>
-          <a:p>
-            <a:r>
-              <a:rPr sz="1200" b="0">
-                <a:solidFill>
-                  <a:srgbClr val="CBD5E1"/>
-                </a:solidFill>
-                <a:latin typeface="Consolas"/>
-              </a:rPr>
-              <a:t>  "preview": { "kind": "html", "entry": true } }</a:t>
-            </a:r>
-          </a:p>
-        </p:txBody>
-      </p:sp>
-      <p:sp>
-        <p:nvSpPr>
-          <p:cNvPr id="21" name="Rounded Rectangle 20"/>
-          <p:cNvSpPr/>
-          <p:nvPr/>
-        </p:nvSpPr>
-        <p:spPr>
-          <a:xfrm>
-            <a:off x="4617720" y="3611880"/>
-            <a:ext cx="3474720" cy="2880360"/>
-          </a:xfrm>
-          <a:prstGeom prst="roundRect">
-            <a:avLst>
-              <a:gd name="adj" fmla="val 8000"/>
-            </a:avLst>
-          </a:prstGeom>
-          <a:solidFill>
-            <a:srgbClr val="0F172A"/>
-          </a:solidFill>
-          <a:ln w="12700">
-            <a:solidFill>
-              <a:srgbClr val="0F172A"/>
-            </a:solidFill>
-          </a:ln>
-        </p:spPr>
-        <p:style>
-          <a:lnRef idx="1">
-            <a:schemeClr val="accent1"/>
-          </a:lnRef>
-          <a:fillRef idx="3">
-            <a:schemeClr val="accent1"/>
-          </a:fillRef>
-          <a:effectRef idx="2">
-            <a:schemeClr val="accent1"/>
-          </a:effectRef>
-          <a:fontRef idx="minor">
-            <a:schemeClr val="lt1"/>
-          </a:fontRef>
-        </p:style>
-        <p:txBody>
-          <a:bodyPr rtlCol="0" anchor="ctr"/>
-          <a:lstStyle/>
-          <a:p>
-            <a:pPr algn="ctr"/>
-          </a:p>
-        </p:txBody>
-      </p:sp>
-      <p:sp>
-        <p:nvSpPr>
-          <p:cNvPr id="22" name="TextBox 21"/>
-          <p:cNvSpPr txBox="1"/>
-          <p:nvPr/>
-        </p:nvSpPr>
-        <p:spPr>
-          <a:xfrm>
-            <a:off x="4754880" y="3749039"/>
-            <a:ext cx="3200400" cy="2606040"/>
-          </a:xfrm>
-          <a:prstGeom prst="rect">
-            <a:avLst/>
-          </a:prstGeom>
-          <a:noFill/>
-        </p:spPr>
-        <p:txBody>
-          <a:bodyPr wrap="square">
-            <a:spAutoFit/>
-          </a:bodyPr>
-          <a:lstStyle/>
-          <a:p>
-            <a:r>
-              <a:rPr sz="1200" b="0">
-                <a:solidFill>
-                  <a:srgbClr val="5EEAD4"/>
-                </a:solidFill>
-                <a:latin typeface="Consolas"/>
-              </a:rPr>
-              <a:t>// 方案 A</a:t>
-            </a:r>
-          </a:p>
-          <a:p>
-            <a:r>
-              <a:rPr sz="1200" b="0">
-                <a:solidFill>
-                  <a:srgbClr val="CBD5E1"/>
-                </a:solidFill>
-                <a:latin typeface="Consolas"/>
-              </a:rPr>
-              <a:t>html = await download(id)</a:t>
-            </a:r>
-          </a:p>
-          <a:p>
-            <a:r>
-              <a:rPr sz="1200" b="0">
-                <a:solidFill>
-                  <a:srgbClr val="CBD5E1"/>
-                </a:solidFill>
-                <a:latin typeface="Consolas"/>
-              </a:rPr>
-              <a:t>iframe.sandbox =</a:t>
-            </a:r>
-          </a:p>
-          <a:p>
-            <a:r>
-              <a:rPr sz="1200" b="0">
-                <a:solidFill>
-                  <a:srgbClr val="CBD5E1"/>
-                </a:solidFill>
-                <a:latin typeface="Consolas"/>
-              </a:rPr>
-              <a:t>  'allow-scripts'</a:t>
-            </a:r>
-          </a:p>
-          <a:p>
-            <a:r>
-              <a:rPr sz="1200" b="0">
-                <a:solidFill>
-                  <a:srgbClr val="CBD5E1"/>
-                </a:solidFill>
-                <a:latin typeface="Consolas"/>
-              </a:rPr>
-              <a:t>iframe.srcdoc = html</a:t>
-            </a:r>
-          </a:p>
-        </p:txBody>
-      </p:sp>
-      <p:sp>
-        <p:nvSpPr>
-          <p:cNvPr id="23" name="Rounded Rectangle 22"/>
-          <p:cNvSpPr/>
-          <p:nvPr/>
-        </p:nvSpPr>
-        <p:spPr>
-          <a:xfrm>
-            <a:off x="8275320" y="3611880"/>
-            <a:ext cx="3520440" cy="2880360"/>
-          </a:xfrm>
-          <a:prstGeom prst="roundRect">
-            <a:avLst>
-              <a:gd name="adj" fmla="val 8000"/>
-            </a:avLst>
-          </a:prstGeom>
-          <a:solidFill>
-            <a:srgbClr val="0F172A"/>
-          </a:solidFill>
-          <a:ln w="12700">
-            <a:solidFill>
-              <a:srgbClr val="0F172A"/>
-            </a:solidFill>
-          </a:ln>
-        </p:spPr>
-        <p:style>
-          <a:lnRef idx="1">
-            <a:schemeClr val="accent1"/>
-          </a:lnRef>
-          <a:fillRef idx="3">
-            <a:schemeClr val="accent1"/>
-          </a:fillRef>
-          <a:effectRef idx="2">
-            <a:schemeClr val="accent1"/>
-          </a:effectRef>
-          <a:fontRef idx="minor">
-            <a:schemeClr val="lt1"/>
-          </a:fontRef>
-        </p:style>
-        <p:txBody>
-          <a:bodyPr rtlCol="0" anchor="ctr"/>
-          <a:lstStyle/>
-          <a:p>
-            <a:pPr algn="ctr"/>
-          </a:p>
-        </p:txBody>
-      </p:sp>
-      <p:sp>
-        <p:nvSpPr>
-          <p:cNvPr id="24" name="TextBox 23"/>
-          <p:cNvSpPr txBox="1"/>
-          <p:nvPr/>
-        </p:nvSpPr>
-        <p:spPr>
-          <a:xfrm>
-            <a:off x="8412480" y="3749039"/>
-            <a:ext cx="3246120" cy="2606040"/>
-          </a:xfrm>
-          <a:prstGeom prst="rect">
-            <a:avLst/>
-          </a:prstGeom>
-          <a:noFill/>
-        </p:spPr>
-        <p:txBody>
-          <a:bodyPr wrap="square">
-            <a:spAutoFit/>
-          </a:bodyPr>
-          <a:lstStyle/>
-          <a:p>
-            <a:r>
-              <a:rPr sz="1200" b="0">
-                <a:solidFill>
-                  <a:srgbClr val="5EEAD4"/>
-                </a:solidFill>
-                <a:latin typeface="Consolas"/>
-              </a:rPr>
-              <a:t>// 方案 C</a:t>
-            </a:r>
-          </a:p>
-          <a:p>
-            <a:r>
-              <a:rPr sz="1200" b="0">
-                <a:solidFill>
-                  <a:srgbClr val="CBD5E1"/>
-                </a:solidFill>
-                <a:latin typeface="Consolas"/>
-              </a:rPr>
-              <a:t>onDelta(t =&gt; paint(buf+=t))</a:t>
-            </a:r>
-          </a:p>
-          <a:p>
-            <a:r>
-              <a:rPr sz="1200" b="0">
-                <a:solidFill>
-                  <a:srgbClr val="CBD5E1"/>
-                </a:solidFill>
-                <a:latin typeface="Consolas"/>
-              </a:rPr>
-              <a:t>onDone(async () =&gt; {</a:t>
-            </a:r>
-          </a:p>
-          <a:p>
-            <a:r>
-              <a:rPr sz="1200" b="0">
-                <a:solidFill>
-                  <a:srgbClr val="CBD5E1"/>
-                </a:solidFill>
-                <a:latin typeface="Consolas"/>
-              </a:rPr>
-              <a:t>  await writeAndSync()</a:t>
-            </a:r>
-          </a:p>
-          <a:p>
-            <a:r>
-              <a:rPr sz="1200" b="0">
-                <a:solidFill>
-                  <a:srgbClr val="CBD5E1"/>
-                </a:solidFill>
-                <a:latin typeface="Consolas"/>
-              </a:rPr>
-              <a:t>  iframe.srcdoc = final</a:t>
-            </a:r>
-          </a:p>
-          <a:p>
-            <a:r>
-              <a:rPr sz="1200" b="0">
-                <a:solidFill>
-                  <a:srgbClr val="CBD5E1"/>
-                </a:solidFill>
-                <a:latin typeface="Consolas"/>
-              </a:rPr>
-              <a:t>})</a:t>
+              <a:t>预览域作渲染入口（可解耦）</a:t>
             </a:r>
           </a:p>
         </p:txBody>
@@ -11313,7 +11116,7 @@
                 </a:solidFill>
                 <a:latin typeface="Calibri"/>
               </a:rPr>
-              <a:t>07</a:t>
+              <a:t>06</a:t>
             </a:r>
           </a:p>
         </p:txBody>
@@ -11347,6 +11150,1160 @@
                 </a:solidFill>
                 <a:latin typeface="Calibri"/>
               </a:rPr>
+              <a:t>实现示例</a:t>
+            </a:r>
+          </a:p>
+          <a:p>
+            <a:r>
+              <a:rPr sz="1100" b="0">
+                <a:solidFill>
+                  <a:srgbClr val="94A3B8"/>
+                </a:solidFill>
+                <a:latin typeface="Calibri"/>
+              </a:rPr>
+              <a:t>健康报告闭环：契约 · 方案 4 主路径 · 方案 A 兜底</a:t>
+            </a:r>
+          </a:p>
+        </p:txBody>
+      </p:sp>
+      <p:sp>
+        <p:nvSpPr>
+          <p:cNvPr id="7" name="Rounded Rectangle 6"/>
+          <p:cNvSpPr/>
+          <p:nvPr/>
+        </p:nvSpPr>
+        <p:spPr>
+          <a:xfrm>
+            <a:off x="320040" y="1097280"/>
+            <a:ext cx="4114800" cy="5394960"/>
+          </a:xfrm>
+          <a:prstGeom prst="roundRect">
+            <a:avLst>
+              <a:gd name="adj" fmla="val 8000"/>
+            </a:avLst>
+          </a:prstGeom>
+          <a:solidFill>
+            <a:srgbClr val="FFFFFF"/>
+          </a:solidFill>
+          <a:ln w="12700">
+            <a:solidFill>
+              <a:srgbClr val="E2E8F0"/>
+            </a:solidFill>
+          </a:ln>
+        </p:spPr>
+        <p:style>
+          <a:lnRef idx="1">
+            <a:schemeClr val="accent1"/>
+          </a:lnRef>
+          <a:fillRef idx="3">
+            <a:schemeClr val="accent1"/>
+          </a:fillRef>
+          <a:effectRef idx="2">
+            <a:schemeClr val="accent1"/>
+          </a:effectRef>
+          <a:fontRef idx="minor">
+            <a:schemeClr val="lt1"/>
+          </a:fontRef>
+        </p:style>
+        <p:txBody>
+          <a:bodyPr rtlCol="0" anchor="ctr"/>
+          <a:lstStyle/>
+          <a:p>
+            <a:pPr algn="ctr"/>
+          </a:p>
+        </p:txBody>
+      </p:sp>
+      <p:sp>
+        <p:nvSpPr>
+          <p:cNvPr id="8" name="TextBox 7"/>
+          <p:cNvSpPr txBox="1"/>
+          <p:nvPr/>
+        </p:nvSpPr>
+        <p:spPr>
+          <a:xfrm>
+            <a:off x="457200" y="1234440"/>
+            <a:ext cx="3840480" cy="365760"/>
+          </a:xfrm>
+          <a:prstGeom prst="rect">
+            <a:avLst/>
+          </a:prstGeom>
+          <a:noFill/>
+        </p:spPr>
+        <p:txBody>
+          <a:bodyPr wrap="square">
+            <a:spAutoFit/>
+          </a:bodyPr>
+          <a:lstStyle/>
+          <a:p>
+            <a:r>
+              <a:rPr sz="1400" b="1">
+                <a:solidFill>
+                  <a:srgbClr val="0D9488"/>
+                </a:solidFill>
+                <a:latin typeface="Calibri"/>
+              </a:rPr>
+              <a:t>健康报告串接（方案 4）</a:t>
+            </a:r>
+          </a:p>
+        </p:txBody>
+      </p:sp>
+      <p:sp>
+        <p:nvSpPr>
+          <p:cNvPr id="9" name="Oval 8"/>
+          <p:cNvSpPr/>
+          <p:nvPr/>
+        </p:nvSpPr>
+        <p:spPr>
+          <a:xfrm>
+            <a:off x="548640" y="1737360"/>
+            <a:ext cx="384048" cy="384048"/>
+          </a:xfrm>
+          <a:prstGeom prst="ellipse">
+            <a:avLst/>
+          </a:prstGeom>
+          <a:solidFill>
+            <a:srgbClr val="0D9488"/>
+          </a:solidFill>
+          <a:ln>
+            <a:noFill/>
+          </a:ln>
+        </p:spPr>
+        <p:style>
+          <a:lnRef idx="1">
+            <a:schemeClr val="accent1"/>
+          </a:lnRef>
+          <a:fillRef idx="3">
+            <a:schemeClr val="accent1"/>
+          </a:fillRef>
+          <a:effectRef idx="2">
+            <a:schemeClr val="accent1"/>
+          </a:effectRef>
+          <a:fontRef idx="minor">
+            <a:schemeClr val="lt1"/>
+          </a:fontRef>
+        </p:style>
+        <p:txBody>
+          <a:bodyPr rtlCol="0" anchor="ctr"/>
+          <a:lstStyle/>
+          <a:p>
+            <a:pPr algn="ctr"/>
+            <a:r>
+              <a:rPr sz="1200" b="1">
+                <a:solidFill>
+                  <a:srgbClr val="FFFFFF"/>
+                </a:solidFill>
+                <a:latin typeface="Calibri"/>
+              </a:rPr>
+              <a:t>1</a:t>
+            </a:r>
+          </a:p>
+        </p:txBody>
+      </p:sp>
+      <p:sp>
+        <p:nvSpPr>
+          <p:cNvPr id="10" name="TextBox 9"/>
+          <p:cNvSpPr txBox="1"/>
+          <p:nvPr/>
+        </p:nvSpPr>
+        <p:spPr>
+          <a:xfrm>
+            <a:off x="1097280" y="1691640"/>
+            <a:ext cx="3108960" cy="731520"/>
+          </a:xfrm>
+          <a:prstGeom prst="rect">
+            <a:avLst/>
+          </a:prstGeom>
+          <a:noFill/>
+        </p:spPr>
+        <p:txBody>
+          <a:bodyPr wrap="square">
+            <a:spAutoFit/>
+          </a:bodyPr>
+          <a:lstStyle/>
+          <a:p>
+            <a:r>
+              <a:rPr sz="1200" b="0">
+                <a:solidFill>
+                  <a:srgbClr val="334155"/>
+                </a:solidFill>
+                <a:latin typeface="Calibri"/>
+              </a:rPr>
+              <a:t>Skill 拉取运动健康数据</a:t>
+            </a:r>
+          </a:p>
+        </p:txBody>
+      </p:sp>
+      <p:sp>
+        <p:nvSpPr>
+          <p:cNvPr id="11" name="Oval 10"/>
+          <p:cNvSpPr/>
+          <p:nvPr/>
+        </p:nvSpPr>
+        <p:spPr>
+          <a:xfrm>
+            <a:off x="548640" y="2606040"/>
+            <a:ext cx="384048" cy="384048"/>
+          </a:xfrm>
+          <a:prstGeom prst="ellipse">
+            <a:avLst/>
+          </a:prstGeom>
+          <a:solidFill>
+            <a:srgbClr val="0D9488"/>
+          </a:solidFill>
+          <a:ln>
+            <a:noFill/>
+          </a:ln>
+        </p:spPr>
+        <p:style>
+          <a:lnRef idx="1">
+            <a:schemeClr val="accent1"/>
+          </a:lnRef>
+          <a:fillRef idx="3">
+            <a:schemeClr val="accent1"/>
+          </a:fillRef>
+          <a:effectRef idx="2">
+            <a:schemeClr val="accent1"/>
+          </a:effectRef>
+          <a:fontRef idx="minor">
+            <a:schemeClr val="lt1"/>
+          </a:fontRef>
+        </p:style>
+        <p:txBody>
+          <a:bodyPr rtlCol="0" anchor="ctr"/>
+          <a:lstStyle/>
+          <a:p>
+            <a:pPr algn="ctr"/>
+            <a:r>
+              <a:rPr sz="1200" b="1">
+                <a:solidFill>
+                  <a:srgbClr val="FFFFFF"/>
+                </a:solidFill>
+                <a:latin typeface="Calibri"/>
+              </a:rPr>
+              <a:t>2</a:t>
+            </a:r>
+          </a:p>
+        </p:txBody>
+      </p:sp>
+      <p:sp>
+        <p:nvSpPr>
+          <p:cNvPr id="12" name="TextBox 11"/>
+          <p:cNvSpPr txBox="1"/>
+          <p:nvPr/>
+        </p:nvSpPr>
+        <p:spPr>
+          <a:xfrm>
+            <a:off x="1097280" y="2560320"/>
+            <a:ext cx="3108960" cy="731520"/>
+          </a:xfrm>
+          <a:prstGeom prst="rect">
+            <a:avLst/>
+          </a:prstGeom>
+          <a:noFill/>
+        </p:spPr>
+        <p:txBody>
+          <a:bodyPr wrap="square">
+            <a:spAutoFit/>
+          </a:bodyPr>
+          <a:lstStyle/>
+          <a:p>
+            <a:r>
+              <a:rPr sz="1200" b="0">
+                <a:solidFill>
+                  <a:srgbClr val="334155"/>
+                </a:solidFill>
+                <a:latin typeface="Calibri"/>
+              </a:rPr>
+              <a:t>生成图表化 HTML 报告</a:t>
+            </a:r>
+          </a:p>
+        </p:txBody>
+      </p:sp>
+      <p:sp>
+        <p:nvSpPr>
+          <p:cNvPr id="13" name="Oval 12"/>
+          <p:cNvSpPr/>
+          <p:nvPr/>
+        </p:nvSpPr>
+        <p:spPr>
+          <a:xfrm>
+            <a:off x="548640" y="3474720"/>
+            <a:ext cx="384048" cy="384048"/>
+          </a:xfrm>
+          <a:prstGeom prst="ellipse">
+            <a:avLst/>
+          </a:prstGeom>
+          <a:solidFill>
+            <a:srgbClr val="0D9488"/>
+          </a:solidFill>
+          <a:ln>
+            <a:noFill/>
+          </a:ln>
+        </p:spPr>
+        <p:style>
+          <a:lnRef idx="1">
+            <a:schemeClr val="accent1"/>
+          </a:lnRef>
+          <a:fillRef idx="3">
+            <a:schemeClr val="accent1"/>
+          </a:fillRef>
+          <a:effectRef idx="2">
+            <a:schemeClr val="accent1"/>
+          </a:effectRef>
+          <a:fontRef idx="minor">
+            <a:schemeClr val="lt1"/>
+          </a:fontRef>
+        </p:style>
+        <p:txBody>
+          <a:bodyPr rtlCol="0" anchor="ctr"/>
+          <a:lstStyle/>
+          <a:p>
+            <a:pPr algn="ctr"/>
+            <a:r>
+              <a:rPr sz="1200" b="1">
+                <a:solidFill>
+                  <a:srgbClr val="FFFFFF"/>
+                </a:solidFill>
+                <a:latin typeface="Calibri"/>
+              </a:rPr>
+              <a:t>3</a:t>
+            </a:r>
+          </a:p>
+        </p:txBody>
+      </p:sp>
+      <p:sp>
+        <p:nvSpPr>
+          <p:cNvPr id="14" name="TextBox 13"/>
+          <p:cNvSpPr txBox="1"/>
+          <p:nvPr/>
+        </p:nvSpPr>
+        <p:spPr>
+          <a:xfrm>
+            <a:off x="1097280" y="3429000"/>
+            <a:ext cx="3108960" cy="731520"/>
+          </a:xfrm>
+          <a:prstGeom prst="rect">
+            <a:avLst/>
+          </a:prstGeom>
+          <a:noFill/>
+        </p:spPr>
+        <p:txBody>
+          <a:bodyPr wrap="square">
+            <a:spAutoFit/>
+          </a:bodyPr>
+          <a:lstStyle/>
+          <a:p>
+            <a:r>
+              <a:rPr sz="1200" b="0">
+                <a:solidFill>
+                  <a:srgbClr val="334155"/>
+                </a:solidFill>
+                <a:latin typeface="Calibri"/>
+              </a:rPr>
+              <a:t>发布到云预览服务</a:t>
+            </a:r>
+          </a:p>
+          <a:p>
+            <a:r>
+              <a:rPr sz="1200" b="0">
+                <a:solidFill>
+                  <a:srgbClr val="334155"/>
+                </a:solidFill>
+                <a:latin typeface="Calibri"/>
+              </a:rPr>
+              <a:t>（源文件仍可 write 云空间）</a:t>
+            </a:r>
+          </a:p>
+        </p:txBody>
+      </p:sp>
+      <p:sp>
+        <p:nvSpPr>
+          <p:cNvPr id="15" name="Oval 14"/>
+          <p:cNvSpPr/>
+          <p:nvPr/>
+        </p:nvSpPr>
+        <p:spPr>
+          <a:xfrm>
+            <a:off x="548640" y="4343399"/>
+            <a:ext cx="384048" cy="384048"/>
+          </a:xfrm>
+          <a:prstGeom prst="ellipse">
+            <a:avLst/>
+          </a:prstGeom>
+          <a:solidFill>
+            <a:srgbClr val="0D9488"/>
+          </a:solidFill>
+          <a:ln>
+            <a:noFill/>
+          </a:ln>
+        </p:spPr>
+        <p:style>
+          <a:lnRef idx="1">
+            <a:schemeClr val="accent1"/>
+          </a:lnRef>
+          <a:fillRef idx="3">
+            <a:schemeClr val="accent1"/>
+          </a:fillRef>
+          <a:effectRef idx="2">
+            <a:schemeClr val="accent1"/>
+          </a:effectRef>
+          <a:fontRef idx="minor">
+            <a:schemeClr val="lt1"/>
+          </a:fontRef>
+        </p:style>
+        <p:txBody>
+          <a:bodyPr rtlCol="0" anchor="ctr"/>
+          <a:lstStyle/>
+          <a:p>
+            <a:pPr algn="ctr"/>
+            <a:r>
+              <a:rPr sz="1200" b="1">
+                <a:solidFill>
+                  <a:srgbClr val="FFFFFF"/>
+                </a:solidFill>
+                <a:latin typeface="Calibri"/>
+              </a:rPr>
+              <a:t>4</a:t>
+            </a:r>
+          </a:p>
+        </p:txBody>
+      </p:sp>
+      <p:sp>
+        <p:nvSpPr>
+          <p:cNvPr id="16" name="TextBox 15"/>
+          <p:cNvSpPr txBox="1"/>
+          <p:nvPr/>
+        </p:nvSpPr>
+        <p:spPr>
+          <a:xfrm>
+            <a:off x="1097280" y="4297679"/>
+            <a:ext cx="3108960" cy="731520"/>
+          </a:xfrm>
+          <a:prstGeom prst="rect">
+            <a:avLst/>
+          </a:prstGeom>
+          <a:noFill/>
+        </p:spPr>
+        <p:txBody>
+          <a:bodyPr wrap="square">
+            <a:spAutoFit/>
+          </a:bodyPr>
+          <a:lstStyle/>
+          <a:p>
+            <a:r>
+              <a:rPr sz="1200" b="0">
+                <a:solidFill>
+                  <a:srgbClr val="334155"/>
+                </a:solidFill>
+                <a:latin typeface="Calibri"/>
+              </a:rPr>
+              <a:t>工具返回 preview_url</a:t>
+            </a:r>
+          </a:p>
+        </p:txBody>
+      </p:sp>
+      <p:sp>
+        <p:nvSpPr>
+          <p:cNvPr id="17" name="Oval 16"/>
+          <p:cNvSpPr/>
+          <p:nvPr/>
+        </p:nvSpPr>
+        <p:spPr>
+          <a:xfrm>
+            <a:off x="548640" y="5212080"/>
+            <a:ext cx="384048" cy="384048"/>
+          </a:xfrm>
+          <a:prstGeom prst="ellipse">
+            <a:avLst/>
+          </a:prstGeom>
+          <a:solidFill>
+            <a:srgbClr val="0D9488"/>
+          </a:solidFill>
+          <a:ln>
+            <a:noFill/>
+          </a:ln>
+        </p:spPr>
+        <p:style>
+          <a:lnRef idx="1">
+            <a:schemeClr val="accent1"/>
+          </a:lnRef>
+          <a:fillRef idx="3">
+            <a:schemeClr val="accent1"/>
+          </a:fillRef>
+          <a:effectRef idx="2">
+            <a:schemeClr val="accent1"/>
+          </a:effectRef>
+          <a:fontRef idx="minor">
+            <a:schemeClr val="lt1"/>
+          </a:fontRef>
+        </p:style>
+        <p:txBody>
+          <a:bodyPr rtlCol="0" anchor="ctr"/>
+          <a:lstStyle/>
+          <a:p>
+            <a:pPr algn="ctr"/>
+            <a:r>
+              <a:rPr sz="1200" b="1">
+                <a:solidFill>
+                  <a:srgbClr val="FFFFFF"/>
+                </a:solidFill>
+                <a:latin typeface="Calibri"/>
+              </a:rPr>
+              <a:t>5</a:t>
+            </a:r>
+          </a:p>
+        </p:txBody>
+      </p:sp>
+      <p:sp>
+        <p:nvSpPr>
+          <p:cNvPr id="18" name="TextBox 17"/>
+          <p:cNvSpPr txBox="1"/>
+          <p:nvPr/>
+        </p:nvSpPr>
+        <p:spPr>
+          <a:xfrm>
+            <a:off x="1097280" y="5166360"/>
+            <a:ext cx="3108960" cy="731520"/>
+          </a:xfrm>
+          <a:prstGeom prst="rect">
+            <a:avLst/>
+          </a:prstGeom>
+          <a:noFill/>
+        </p:spPr>
+        <p:txBody>
+          <a:bodyPr wrap="square">
+            <a:spAutoFit/>
+          </a:bodyPr>
+          <a:lstStyle/>
+          <a:p>
+            <a:r>
+              <a:rPr sz="1200" b="0">
+                <a:solidFill>
+                  <a:srgbClr val="334155"/>
+                </a:solidFill>
+                <a:latin typeface="Calibri"/>
+              </a:rPr>
+              <a:t>WebView 直接打开链接</a:t>
+            </a:r>
+          </a:p>
+        </p:txBody>
+      </p:sp>
+      <p:sp>
+        <p:nvSpPr>
+          <p:cNvPr id="19" name="Rounded Rectangle 18"/>
+          <p:cNvSpPr/>
+          <p:nvPr/>
+        </p:nvSpPr>
+        <p:spPr>
+          <a:xfrm>
+            <a:off x="4617720" y="1097280"/>
+            <a:ext cx="7178040" cy="2331720"/>
+          </a:xfrm>
+          <a:prstGeom prst="roundRect">
+            <a:avLst>
+              <a:gd name="adj" fmla="val 8000"/>
+            </a:avLst>
+          </a:prstGeom>
+          <a:solidFill>
+            <a:srgbClr val="0F172A"/>
+          </a:solidFill>
+          <a:ln w="12700">
+            <a:solidFill>
+              <a:srgbClr val="0F172A"/>
+            </a:solidFill>
+          </a:ln>
+        </p:spPr>
+        <p:style>
+          <a:lnRef idx="1">
+            <a:schemeClr val="accent1"/>
+          </a:lnRef>
+          <a:fillRef idx="3">
+            <a:schemeClr val="accent1"/>
+          </a:fillRef>
+          <a:effectRef idx="2">
+            <a:schemeClr val="accent1"/>
+          </a:effectRef>
+          <a:fontRef idx="minor">
+            <a:schemeClr val="lt1"/>
+          </a:fontRef>
+        </p:style>
+        <p:txBody>
+          <a:bodyPr rtlCol="0" anchor="ctr"/>
+          <a:lstStyle/>
+          <a:p>
+            <a:pPr algn="ctr"/>
+          </a:p>
+        </p:txBody>
+      </p:sp>
+      <p:sp>
+        <p:nvSpPr>
+          <p:cNvPr id="20" name="TextBox 19"/>
+          <p:cNvSpPr txBox="1"/>
+          <p:nvPr/>
+        </p:nvSpPr>
+        <p:spPr>
+          <a:xfrm>
+            <a:off x="4800600" y="1234440"/>
+            <a:ext cx="6858000" cy="2057400"/>
+          </a:xfrm>
+          <a:prstGeom prst="rect">
+            <a:avLst/>
+          </a:prstGeom>
+          <a:noFill/>
+        </p:spPr>
+        <p:txBody>
+          <a:bodyPr wrap="square">
+            <a:spAutoFit/>
+          </a:bodyPr>
+          <a:lstStyle/>
+          <a:p>
+            <a:r>
+              <a:rPr sz="1200" b="0">
+                <a:solidFill>
+                  <a:srgbClr val="5EEAD4"/>
+                </a:solidFill>
+                <a:latin typeface="Consolas"/>
+              </a:rPr>
+              <a:t>// 方案 4：发布后的工具返回（示意）</a:t>
+            </a:r>
+          </a:p>
+          <a:p>
+            <a:r>
+              <a:rPr sz="1200" b="0">
+                <a:solidFill>
+                  <a:srgbClr val="CBD5E1"/>
+                </a:solidFill>
+                <a:latin typeface="Consolas"/>
+              </a:rPr>
+              <a:t>{ "preview_url": "https://preview.xxx/p/abc/",</a:t>
+            </a:r>
+          </a:p>
+          <a:p>
+            <a:r>
+              <a:rPr sz="1200" b="0">
+                <a:solidFill>
+                  <a:srgbClr val="CBD5E1"/>
+                </a:solidFill>
+                <a:latin typeface="Consolas"/>
+              </a:rPr>
+              <a:t>  "expires_at": "2026-08-01T00:00:00Z",</a:t>
+            </a:r>
+          </a:p>
+          <a:p>
+            <a:r>
+              <a:rPr sz="1200" b="0">
+                <a:solidFill>
+                  <a:srgbClr val="CBD5E1"/>
+                </a:solidFill>
+                <a:latin typeface="Consolas"/>
+              </a:rPr>
+              <a:t>  "mime": "text/html",</a:t>
+            </a:r>
+          </a:p>
+          <a:p>
+            <a:r>
+              <a:rPr sz="1200" b="0">
+                <a:solidFill>
+                  <a:srgbClr val="CBD5E1"/>
+                </a:solidFill>
+                <a:latin typeface="Consolas"/>
+              </a:rPr>
+              <a:t>  "source_file_id": "f_xxx"  // 可选，云空间源文件 }</a:t>
+            </a:r>
+          </a:p>
+        </p:txBody>
+      </p:sp>
+      <p:sp>
+        <p:nvSpPr>
+          <p:cNvPr id="21" name="Rounded Rectangle 20"/>
+          <p:cNvSpPr/>
+          <p:nvPr/>
+        </p:nvSpPr>
+        <p:spPr>
+          <a:xfrm>
+            <a:off x="4617720" y="3611880"/>
+            <a:ext cx="3474720" cy="2880360"/>
+          </a:xfrm>
+          <a:prstGeom prst="roundRect">
+            <a:avLst>
+              <a:gd name="adj" fmla="val 8000"/>
+            </a:avLst>
+          </a:prstGeom>
+          <a:solidFill>
+            <a:srgbClr val="0F172A"/>
+          </a:solidFill>
+          <a:ln w="12700">
+            <a:solidFill>
+              <a:srgbClr val="0F172A"/>
+            </a:solidFill>
+          </a:ln>
+        </p:spPr>
+        <p:style>
+          <a:lnRef idx="1">
+            <a:schemeClr val="accent1"/>
+          </a:lnRef>
+          <a:fillRef idx="3">
+            <a:schemeClr val="accent1"/>
+          </a:fillRef>
+          <a:effectRef idx="2">
+            <a:schemeClr val="accent1"/>
+          </a:effectRef>
+          <a:fontRef idx="minor">
+            <a:schemeClr val="lt1"/>
+          </a:fontRef>
+        </p:style>
+        <p:txBody>
+          <a:bodyPr rtlCol="0" anchor="ctr"/>
+          <a:lstStyle/>
+          <a:p>
+            <a:pPr algn="ctr"/>
+          </a:p>
+        </p:txBody>
+      </p:sp>
+      <p:sp>
+        <p:nvSpPr>
+          <p:cNvPr id="22" name="TextBox 21"/>
+          <p:cNvSpPr txBox="1"/>
+          <p:nvPr/>
+        </p:nvSpPr>
+        <p:spPr>
+          <a:xfrm>
+            <a:off x="4754880" y="3749039"/>
+            <a:ext cx="3200400" cy="2606040"/>
+          </a:xfrm>
+          <a:prstGeom prst="rect">
+            <a:avLst/>
+          </a:prstGeom>
+          <a:noFill/>
+        </p:spPr>
+        <p:txBody>
+          <a:bodyPr wrap="square">
+            <a:spAutoFit/>
+          </a:bodyPr>
+          <a:lstStyle/>
+          <a:p>
+            <a:r>
+              <a:rPr sz="1100" b="0">
+                <a:solidFill>
+                  <a:srgbClr val="5EEAD4"/>
+                </a:solidFill>
+                <a:latin typeface="Consolas"/>
+              </a:rPr>
+              <a:t>// 方案 4 · 端侧</a:t>
+            </a:r>
+          </a:p>
+          <a:p>
+            <a:r>
+              <a:rPr sz="1100" b="0">
+                <a:solidFill>
+                  <a:srgbClr val="CBD5E1"/>
+                </a:solidFill>
+                <a:latin typeface="Consolas"/>
+              </a:rPr>
+              <a:t>webView.settings.javaScript</a:t>
+            </a:r>
+          </a:p>
+          <a:p>
+            <a:r>
+              <a:rPr sz="1100" b="0">
+                <a:solidFill>
+                  <a:srgbClr val="CBD5E1"/>
+                </a:solidFill>
+                <a:latin typeface="Consolas"/>
+              </a:rPr>
+              <a:t>  Enabled = true</a:t>
+            </a:r>
+          </a:p>
+          <a:p>
+            <a:r>
+              <a:rPr sz="1100" b="0">
+                <a:solidFill>
+                  <a:srgbClr val="CBD5E1"/>
+                </a:solidFill>
+                <a:latin typeface="Consolas"/>
+              </a:rPr>
+              <a:t>webView.loadUrl(previewUrl)</a:t>
+            </a:r>
+          </a:p>
+          <a:p>
+            <a:r>
+              <a:rPr sz="1100" b="0">
+                <a:solidFill>
+                  <a:srgbClr val="CBD5E1"/>
+                </a:solidFill>
+                <a:latin typeface="Consolas"/>
+              </a:rPr>
+              <a:t>// 或 iframe.src = url</a:t>
+            </a:r>
+          </a:p>
+          <a:p>
+            <a:r>
+              <a:rPr sz="1100" b="0">
+                <a:solidFill>
+                  <a:srgbClr val="CBD5E1"/>
+                </a:solidFill>
+                <a:latin typeface="Consolas"/>
+              </a:rPr>
+              <a:t>// + sandbox=allow-scripts</a:t>
+            </a:r>
+          </a:p>
+        </p:txBody>
+      </p:sp>
+      <p:sp>
+        <p:nvSpPr>
+          <p:cNvPr id="23" name="Rounded Rectangle 22"/>
+          <p:cNvSpPr/>
+          <p:nvPr/>
+        </p:nvSpPr>
+        <p:spPr>
+          <a:xfrm>
+            <a:off x="8275320" y="3611880"/>
+            <a:ext cx="3520440" cy="2880360"/>
+          </a:xfrm>
+          <a:prstGeom prst="roundRect">
+            <a:avLst>
+              <a:gd name="adj" fmla="val 8000"/>
+            </a:avLst>
+          </a:prstGeom>
+          <a:solidFill>
+            <a:srgbClr val="0F172A"/>
+          </a:solidFill>
+          <a:ln w="12700">
+            <a:solidFill>
+              <a:srgbClr val="0F172A"/>
+            </a:solidFill>
+          </a:ln>
+        </p:spPr>
+        <p:style>
+          <a:lnRef idx="1">
+            <a:schemeClr val="accent1"/>
+          </a:lnRef>
+          <a:fillRef idx="3">
+            <a:schemeClr val="accent1"/>
+          </a:fillRef>
+          <a:effectRef idx="2">
+            <a:schemeClr val="accent1"/>
+          </a:effectRef>
+          <a:fontRef idx="minor">
+            <a:schemeClr val="lt1"/>
+          </a:fontRef>
+        </p:style>
+        <p:txBody>
+          <a:bodyPr rtlCol="0" anchor="ctr"/>
+          <a:lstStyle/>
+          <a:p>
+            <a:pPr algn="ctr"/>
+          </a:p>
+        </p:txBody>
+      </p:sp>
+      <p:sp>
+        <p:nvSpPr>
+          <p:cNvPr id="24" name="TextBox 23"/>
+          <p:cNvSpPr txBox="1"/>
+          <p:nvPr/>
+        </p:nvSpPr>
+        <p:spPr>
+          <a:xfrm>
+            <a:off x="8412480" y="3749039"/>
+            <a:ext cx="3246120" cy="2606040"/>
+          </a:xfrm>
+          <a:prstGeom prst="rect">
+            <a:avLst/>
+          </a:prstGeom>
+          <a:noFill/>
+        </p:spPr>
+        <p:txBody>
+          <a:bodyPr wrap="square">
+            <a:spAutoFit/>
+          </a:bodyPr>
+          <a:lstStyle/>
+          <a:p>
+            <a:r>
+              <a:rPr sz="1200" b="0">
+                <a:solidFill>
+                  <a:srgbClr val="5EEAD4"/>
+                </a:solidFill>
+                <a:latin typeface="Consolas"/>
+              </a:rPr>
+              <a:t>// 方案 A · 兜底</a:t>
+            </a:r>
+          </a:p>
+          <a:p>
+            <a:r>
+              <a:rPr sz="1200" b="0">
+                <a:solidFill>
+                  <a:srgbClr val="CBD5E1"/>
+                </a:solidFill>
+                <a:latin typeface="Consolas"/>
+              </a:rPr>
+              <a:t>html = await download(id)</a:t>
+            </a:r>
+          </a:p>
+          <a:p>
+            <a:r>
+              <a:rPr sz="1200" b="0">
+                <a:solidFill>
+                  <a:srgbClr val="CBD5E1"/>
+                </a:solidFill>
+                <a:latin typeface="Consolas"/>
+              </a:rPr>
+              <a:t>iframe.sandbox =</a:t>
+            </a:r>
+          </a:p>
+          <a:p>
+            <a:r>
+              <a:rPr sz="1200" b="0">
+                <a:solidFill>
+                  <a:srgbClr val="CBD5E1"/>
+                </a:solidFill>
+                <a:latin typeface="Consolas"/>
+              </a:rPr>
+              <a:t>  'allow-scripts'</a:t>
+            </a:r>
+          </a:p>
+          <a:p>
+            <a:r>
+              <a:rPr sz="1200" b="0">
+                <a:solidFill>
+                  <a:srgbClr val="CBD5E1"/>
+                </a:solidFill>
+                <a:latin typeface="Consolas"/>
+              </a:rPr>
+              <a:t>iframe.srcdoc = html</a:t>
+            </a:r>
+          </a:p>
+        </p:txBody>
+      </p:sp>
+    </p:spTree>
+  </p:cSld>
+  <p:clrMapOvr>
+    <a:masterClrMapping/>
+  </p:clrMapOvr>
+</p:sld>
+</file>
+
+<file path=ppt/slides/slide9.xml><?xml version="1.0" encoding="utf-8"?>
+<p:sld xmlns:a="http://schemas.openxmlformats.org/drawingml/2006/main" xmlns:p="http://schemas.openxmlformats.org/presentationml/2006/main" xmlns:r="http://schemas.openxmlformats.org/officeDocument/2006/relationships">
+  <p:cSld>
+    <p:spTree>
+      <p:nvGrpSpPr>
+        <p:cNvPr id="1" name=""/>
+        <p:cNvGrpSpPr/>
+        <p:nvPr/>
+      </p:nvGrpSpPr>
+      <p:grpSpPr/>
+      <p:sp>
+        <p:nvSpPr>
+          <p:cNvPr id="2" name="Rectangle 1"/>
+          <p:cNvSpPr/>
+          <p:nvPr/>
+        </p:nvSpPr>
+        <p:spPr>
+          <a:xfrm>
+            <a:off x="0" y="0"/>
+            <a:ext cx="12191695" cy="6858000"/>
+          </a:xfrm>
+          <a:prstGeom prst="rect">
+            <a:avLst/>
+          </a:prstGeom>
+          <a:solidFill>
+            <a:srgbClr val="F8FAFC"/>
+          </a:solidFill>
+          <a:ln>
+            <a:noFill/>
+          </a:ln>
+        </p:spPr>
+        <p:style>
+          <a:lnRef idx="1">
+            <a:schemeClr val="accent1"/>
+          </a:lnRef>
+          <a:fillRef idx="3">
+            <a:schemeClr val="accent1"/>
+          </a:fillRef>
+          <a:effectRef idx="2">
+            <a:schemeClr val="accent1"/>
+          </a:effectRef>
+          <a:fontRef idx="minor">
+            <a:schemeClr val="lt1"/>
+          </a:fontRef>
+        </p:style>
+        <p:txBody>
+          <a:bodyPr rtlCol="0" anchor="ctr"/>
+          <a:lstStyle/>
+          <a:p>
+            <a:pPr algn="ctr"/>
+          </a:p>
+        </p:txBody>
+      </p:sp>
+      <p:sp>
+        <p:nvSpPr>
+          <p:cNvPr id="3" name="Rectangle 2"/>
+          <p:cNvSpPr/>
+          <p:nvPr/>
+        </p:nvSpPr>
+        <p:spPr>
+          <a:xfrm>
+            <a:off x="0" y="0"/>
+            <a:ext cx="12191695" cy="868680"/>
+          </a:xfrm>
+          <a:prstGeom prst="rect">
+            <a:avLst/>
+          </a:prstGeom>
+          <a:solidFill>
+            <a:srgbClr val="0F172A"/>
+          </a:solidFill>
+          <a:ln>
+            <a:noFill/>
+          </a:ln>
+        </p:spPr>
+        <p:style>
+          <a:lnRef idx="1">
+            <a:schemeClr val="accent1"/>
+          </a:lnRef>
+          <a:fillRef idx="3">
+            <a:schemeClr val="accent1"/>
+          </a:fillRef>
+          <a:effectRef idx="2">
+            <a:schemeClr val="accent1"/>
+          </a:effectRef>
+          <a:fontRef idx="minor">
+            <a:schemeClr val="lt1"/>
+          </a:fontRef>
+        </p:style>
+        <p:txBody>
+          <a:bodyPr rtlCol="0" anchor="ctr"/>
+          <a:lstStyle/>
+          <a:p>
+            <a:pPr algn="ctr"/>
+          </a:p>
+        </p:txBody>
+      </p:sp>
+      <p:sp>
+        <p:nvSpPr>
+          <p:cNvPr id="4" name="Rectangle 3"/>
+          <p:cNvSpPr/>
+          <p:nvPr/>
+        </p:nvSpPr>
+        <p:spPr>
+          <a:xfrm>
+            <a:off x="0" y="868680"/>
+            <a:ext cx="12191695" cy="54864"/>
+          </a:xfrm>
+          <a:prstGeom prst="rect">
+            <a:avLst/>
+          </a:prstGeom>
+          <a:solidFill>
+            <a:srgbClr val="0D9488"/>
+          </a:solidFill>
+          <a:ln>
+            <a:noFill/>
+          </a:ln>
+        </p:spPr>
+        <p:style>
+          <a:lnRef idx="1">
+            <a:schemeClr val="accent1"/>
+          </a:lnRef>
+          <a:fillRef idx="3">
+            <a:schemeClr val="accent1"/>
+          </a:fillRef>
+          <a:effectRef idx="2">
+            <a:schemeClr val="accent1"/>
+          </a:effectRef>
+          <a:fontRef idx="minor">
+            <a:schemeClr val="lt1"/>
+          </a:fontRef>
+        </p:style>
+        <p:txBody>
+          <a:bodyPr rtlCol="0" anchor="ctr"/>
+          <a:lstStyle/>
+          <a:p>
+            <a:pPr algn="ctr"/>
+          </a:p>
+        </p:txBody>
+      </p:sp>
+      <p:sp>
+        <p:nvSpPr>
+          <p:cNvPr id="5" name="Rounded Rectangle 4"/>
+          <p:cNvSpPr/>
+          <p:nvPr/>
+        </p:nvSpPr>
+        <p:spPr>
+          <a:xfrm>
+            <a:off x="411480" y="201168"/>
+            <a:ext cx="502920" cy="457200"/>
+          </a:xfrm>
+          <a:prstGeom prst="roundRect">
+            <a:avLst>
+              <a:gd name="adj" fmla="val 30000"/>
+            </a:avLst>
+          </a:prstGeom>
+          <a:solidFill>
+            <a:srgbClr val="0D9488"/>
+          </a:solidFill>
+          <a:ln>
+            <a:noFill/>
+          </a:ln>
+        </p:spPr>
+        <p:style>
+          <a:lnRef idx="1">
+            <a:schemeClr val="accent1"/>
+          </a:lnRef>
+          <a:fillRef idx="3">
+            <a:schemeClr val="accent1"/>
+          </a:fillRef>
+          <a:effectRef idx="2">
+            <a:schemeClr val="accent1"/>
+          </a:effectRef>
+          <a:fontRef idx="minor">
+            <a:schemeClr val="lt1"/>
+          </a:fontRef>
+        </p:style>
+        <p:txBody>
+          <a:bodyPr rtlCol="0" anchor="ctr"/>
+          <a:lstStyle/>
+          <a:p>
+            <a:pPr algn="ctr"/>
+            <a:r>
+              <a:rPr sz="1400" b="1">
+                <a:solidFill>
+                  <a:srgbClr val="FFFFFF"/>
+                </a:solidFill>
+                <a:latin typeface="Calibri"/>
+              </a:rPr>
+              <a:t>07</a:t>
+            </a:r>
+          </a:p>
+        </p:txBody>
+      </p:sp>
+      <p:sp>
+        <p:nvSpPr>
+          <p:cNvPr id="6" name="TextBox 5"/>
+          <p:cNvSpPr txBox="1"/>
+          <p:nvPr/>
+        </p:nvSpPr>
+        <p:spPr>
+          <a:xfrm>
+            <a:off x="1051560" y="164592"/>
+            <a:ext cx="10515600" cy="640080"/>
+          </a:xfrm>
+          <a:prstGeom prst="rect">
+            <a:avLst/>
+          </a:prstGeom>
+          <a:noFill/>
+        </p:spPr>
+        <p:txBody>
+          <a:bodyPr wrap="square">
+            <a:spAutoFit/>
+          </a:bodyPr>
+          <a:lstStyle/>
+          <a:p>
+            <a:r>
+              <a:rPr sz="2200" b="1">
+                <a:solidFill>
+                  <a:srgbClr val="FFFFFF"/>
+                </a:solidFill>
+                <a:latin typeface="Calibri"/>
+              </a:rPr>
               <a:t>结论与建议</a:t>
             </a:r>
           </a:p>
@@ -11358,7 +12315,7 @@
                 </a:solidFill>
                 <a:latin typeface="Calibri"/>
               </a:rPr>
-              <a:t>用最少改动打通「对话里看得见的健康报告」</a:t>
+              <a:t>方案 4 作 Web 渲染中台；A 作轻量兜底；B/C 作体验增强</a:t>
             </a:r>
           </a:p>
         </p:txBody>
@@ -11674,7 +12631,7 @@
                 </a:solidFill>
                 <a:latin typeface="Calibri"/>
               </a:rPr>
-              <a:t>能力优先级</a:t>
+              <a:t>方案 4 定位</a:t>
             </a:r>
           </a:p>
         </p:txBody>
@@ -11708,7 +12665,7 @@
                 </a:solidFill>
                 <a:latin typeface="Calibri"/>
               </a:rPr>
-              <a:t>先补渲染 + 安全</a:t>
+              <a:t>云预览服务生成可渲染链接</a:t>
             </a:r>
           </a:p>
           <a:p>
@@ -11724,7 +12681,7 @@
                 </a:solidFill>
                 <a:latin typeface="Calibri"/>
               </a:rPr>
-              <a:t>分享与流式后置</a:t>
+              <a:t>WebView 直接打开——中台主路径</a:t>
             </a:r>
           </a:p>
         </p:txBody>
@@ -11857,7 +12814,7 @@
                 </a:solidFill>
                 <a:latin typeface="Calibri"/>
               </a:rPr>
-              <a:t>竞品对标</a:t>
+              <a:t>与云空间</a:t>
             </a:r>
           </a:p>
         </p:txBody>
@@ -11891,7 +12848,7 @@
                 </a:solidFill>
                 <a:latin typeface="Calibri"/>
               </a:rPr>
-              <a:t>Claude Artifacts / OpenClaw Widget</a:t>
+              <a:t>云空间作源文件仓；预览域作</a:t>
             </a:r>
           </a:p>
           <a:p>
@@ -11907,7 +12864,7 @@
                 </a:solidFill>
                 <a:latin typeface="Calibri"/>
               </a:rPr>
-              <a:t>分享演进参考 Manus</a:t>
+              <a:t>HTTP 渲染入口（可解耦）</a:t>
             </a:r>
           </a:p>
         </p:txBody>
@@ -12040,7 +12997,7 @@
                 </a:solidFill>
                 <a:latin typeface="Calibri"/>
               </a:rPr>
-              <a:t>方案选择</a:t>
+              <a:t>方案组合</a:t>
             </a:r>
           </a:p>
         </p:txBody>
@@ -12074,7 +13031,7 @@
                 </a:solidFill>
                 <a:latin typeface="Calibri"/>
               </a:rPr>
-              <a:t>一期默认 A；报告场景演进 C</a:t>
+              <a:t>主路径 D；兜底 A；长等待用 C</a:t>
             </a:r>
           </a:p>
           <a:p>
@@ -12257,7 +13214,7 @@
                 </a:solidFill>
                 <a:latin typeface="Calibri"/>
               </a:rPr>
-              <a:t>模型 HTML = 不可信</a:t>
+              <a:t>独立预览域 + CSP/TTL</a:t>
             </a:r>
           </a:p>
           <a:p>
@@ -12273,7 +13230,7 @@
                 </a:solidFill>
                 <a:latin typeface="Calibri"/>
               </a:rPr>
-              <a:t>allow-scripts，慎开 same-origin</a:t>
+              <a:t>WebView 仍建议 sandbox 思维</a:t>
             </a:r>
           </a:p>
         </p:txBody>
@@ -12440,7 +13397,7 @@
                 </a:solidFill>
                 <a:latin typeface="Calibri"/>
               </a:rPr>
-              <a:t>元数据 + 预览卡片 + sandbox</a:t>
+              <a:t>预览发布 API + 短链 URL</a:t>
             </a:r>
           </a:p>
           <a:p>
@@ -12456,7 +13413,7 @@
                 </a:solidFill>
                 <a:latin typeface="Calibri"/>
               </a:rPr>
-              <a:t>用健康报告做验收</a:t>
+              <a:t>健康报告验收：会话内 loadUrl</a:t>
             </a:r>
           </a:p>
         </p:txBody>

</xml_diff>